<commit_message>
Update Agentic AI deck: PCB accuracy proof, corrected test count, punchy notes
- Add "PCB photo -> BOM -> should-cost" slide with the live ECU Manual-vs-AI
  proof (total £73 manual vs £69.11 AI) and the five accuracy-hardening fixes
  (empty-BOM fix, catalogue grounding, class-median cap + magnitude guard,
  deterministic fabrication, confirmed-vs-verify split).
- Correct stale automated-test count to 917 passing (77 suites) across the
  executive summary, results table and next-steps status.
- Rewrite all 20 speaker notes: humanised, professional, presenter-punchy.

Co-Authored-By: Claude Opus 4.8 <noreply@anthropic.com>
Claude-Session: https://claude.ai/code/session_0142L4rKS2AV8rxQTDWMs7dy
</commit_message>
<xml_diff>
--- a/CostVision-Agentic-AI-Management-Presentation.pptx
+++ b/CostVision-Agentic-AI-Management-Presentation.pptx
@@ -24,6 +24,7 @@
     <p:sldId id="272" r:id="rId24"/>
     <p:sldId id="273" r:id="rId25"/>
     <p:sldId id="274" r:id="rId26"/>
+    <p:sldId id="275" r:id="rId27"/>
   </p:sldIdLst>
   <p:sldSz cx="12191695" cy="6858000" type="screen4x3"/>
   <p:notesSz cx="6858000" cy="9144000"/>
@@ -554,6 +555,265 @@
 </c:chartSpace>
 </file>
 
+<file path=ppt/charts/chart3.xml><?xml version="1.0" encoding="utf-8"?>
+<c:chartSpace xmlns:c="http://schemas.openxmlformats.org/drawingml/2006/chart" xmlns:a="http://schemas.openxmlformats.org/drawingml/2006/main" xmlns:r="http://schemas.openxmlformats.org/officeDocument/2006/relationships">
+  <c:date1904 val="0"/>
+  <c:chart>
+    <c:autoTitleDeleted val="0"/>
+    <c:plotArea>
+      <c:barChart>
+        <c:barDir val="col"/>
+        <c:grouping val="clustered"/>
+        <c:ser>
+          <c:idx val="0"/>
+          <c:order val="0"/>
+          <c:tx>
+            <c:strRef>
+              <c:f>Sheet1!$B$1</c:f>
+              <c:strCache>
+                <c:ptCount val="1"/>
+                <c:pt idx="0">
+                  <c:v>Manual (engineer)</c:v>
+                </c:pt>
+              </c:strCache>
+            </c:strRef>
+          </c:tx>
+          <c:spPr>
+            <a:solidFill>
+              <a:srgbClr val="64748B"/>
+            </a:solidFill>
+            <a:ln>
+              <a:noFill/>
+            </a:ln>
+          </c:spPr>
+          <c:cat>
+            <c:strRef>
+              <c:f>Sheet1!$A$2:$A$4</c:f>
+              <c:strCache>
+                <c:ptCount val="3"/>
+                <c:pt idx="0">
+                  <c:v>Components</c:v>
+                </c:pt>
+                <c:pt idx="1">
+                  <c:v>Fab + assembly</c:v>
+                </c:pt>
+                <c:pt idx="2">
+                  <c:v>Total / board</c:v>
+                </c:pt>
+              </c:strCache>
+            </c:strRef>
+          </c:cat>
+          <c:val>
+            <c:numRef>
+              <c:f>Sheet1!$B$2:$B$4</c:f>
+              <c:numCache>
+                <c:formatCode>General</c:formatCode>
+                <c:ptCount val="3"/>
+                <c:pt idx="0">
+                  <c:v>62.0</c:v>
+                </c:pt>
+                <c:pt idx="1">
+                  <c:v>10.0</c:v>
+                </c:pt>
+                <c:pt idx="2">
+                  <c:v>73.0</c:v>
+                </c:pt>
+              </c:numCache>
+            </c:numRef>
+          </c:val>
+        </c:ser>
+        <c:ser>
+          <c:idx val="1"/>
+          <c:order val="1"/>
+          <c:tx>
+            <c:strRef>
+              <c:f>Sheet1!$C$1</c:f>
+              <c:strCache>
+                <c:ptCount val="1"/>
+                <c:pt idx="0">
+                  <c:v>AI (from photo)</c:v>
+                </c:pt>
+              </c:strCache>
+            </c:strRef>
+          </c:tx>
+          <c:spPr>
+            <a:solidFill>
+              <a:srgbClr val="2563EB"/>
+            </a:solidFill>
+            <a:ln>
+              <a:noFill/>
+            </a:ln>
+          </c:spPr>
+          <c:cat>
+            <c:strRef>
+              <c:f>Sheet1!$A$2:$A$4</c:f>
+              <c:strCache>
+                <c:ptCount val="3"/>
+                <c:pt idx="0">
+                  <c:v>Components</c:v>
+                </c:pt>
+                <c:pt idx="1">
+                  <c:v>Fab + assembly</c:v>
+                </c:pt>
+                <c:pt idx="2">
+                  <c:v>Total / board</c:v>
+                </c:pt>
+              </c:strCache>
+            </c:strRef>
+          </c:cat>
+          <c:val>
+            <c:numRef>
+              <c:f>Sheet1!$C$2:$C$4</c:f>
+              <c:numCache>
+                <c:formatCode>General</c:formatCode>
+                <c:ptCount val="3"/>
+                <c:pt idx="0">
+                  <c:v>62.29</c:v>
+                </c:pt>
+                <c:pt idx="1">
+                  <c:v>6.82</c:v>
+                </c:pt>
+                <c:pt idx="2">
+                  <c:v>69.11</c:v>
+                </c:pt>
+              </c:numCache>
+            </c:numRef>
+          </c:val>
+        </c:ser>
+        <c:dLbls>
+          <c:txPr>
+            <a:bodyPr/>
+            <a:lstStyle/>
+            <a:p>
+              <a:pPr>
+                <a:defRPr sz="1050" b="1">
+                  <a:solidFill>
+                    <a:srgbClr val="0F172A"/>
+                  </a:solidFill>
+                </a:defRPr>
+              </a:pPr>
+            </a:p>
+          </c:txPr>
+          <c:showLegendKey val="0"/>
+          <c:showVal val="1"/>
+          <c:showCatName val="0"/>
+          <c:showSerName val="0"/>
+          <c:showPercent val="0"/>
+          <c:showBubbleSize val="0"/>
+          <c:showLeaderLines val="1"/>
+        </c:dLbls>
+        <c:axId val="-2068027336"/>
+        <c:axId val="-2113994440"/>
+      </c:barChart>
+      <c:catAx>
+        <c:axId val="-2068027336"/>
+        <c:scaling>
+          <c:orientation val="minMax"/>
+        </c:scaling>
+        <c:delete val="0"/>
+        <c:axPos val="b"/>
+        <c:majorTickMark val="out"/>
+        <c:minorTickMark val="none"/>
+        <c:tickLblPos val="nextTo"/>
+        <c:spPr>
+          <a:ln>
+            <a:solidFill>
+              <a:srgbClr val="E2E8F0"/>
+            </a:solidFill>
+          </a:ln>
+        </c:spPr>
+        <c:txPr>
+          <a:bodyPr/>
+          <a:lstStyle/>
+          <a:p>
+            <a:pPr>
+              <a:defRPr sz="1050">
+                <a:solidFill>
+                  <a:srgbClr val="334155"/>
+                </a:solidFill>
+              </a:defRPr>
+            </a:pPr>
+          </a:p>
+        </c:txPr>
+        <c:crossAx val="-2113994440"/>
+        <c:crosses val="autoZero"/>
+        <c:auto val="1"/>
+        <c:lblAlgn val="ctr"/>
+        <c:lblOffset val="100"/>
+        <c:noMultiLvlLbl val="0"/>
+      </c:catAx>
+      <c:valAx>
+        <c:axId val="-2113994440"/>
+        <c:scaling/>
+        <c:delete val="0"/>
+        <c:axPos val="l"/>
+        <c:majorGridlines>
+          <c:spPr>
+            <a:ln>
+              <a:solidFill>
+                <a:srgbClr val="E2E8F0"/>
+              </a:solidFill>
+            </a:ln>
+          </c:spPr>
+        </c:majorGridlines>
+        <c:majorTickMark val="out"/>
+        <c:minorTickMark val="none"/>
+        <c:tickLblPos val="nextTo"/>
+        <c:spPr>
+          <a:ln>
+            <a:solidFill>
+              <a:srgbClr val="E2E8F0"/>
+            </a:solidFill>
+          </a:ln>
+        </c:spPr>
+        <c:txPr>
+          <a:bodyPr/>
+          <a:lstStyle/>
+          <a:p>
+            <a:pPr>
+              <a:defRPr sz="1000">
+                <a:solidFill>
+                  <a:srgbClr val="64748B"/>
+                </a:solidFill>
+              </a:defRPr>
+            </a:pPr>
+          </a:p>
+        </c:txPr>
+        <c:crossAx val="-2068027336"/>
+        <c:crosses val="autoZero"/>
+      </c:valAx>
+    </c:plotArea>
+    <c:legend>
+      <c:legendPos val="b"/>
+      <c:overlay val="0"/>
+      <c:txPr>
+        <a:bodyPr/>
+        <a:lstStyle/>
+        <a:p>
+          <a:pPr>
+            <a:defRPr sz="1050"/>
+          </a:pPr>
+        </a:p>
+      </c:txPr>
+    </c:legend>
+    <c:dispBlanksAs val="gap"/>
+  </c:chart>
+  <c:txPr>
+    <a:bodyPr/>
+    <a:lstStyle/>
+    <a:p>
+      <a:pPr>
+        <a:defRPr sz="1800"/>
+      </a:pPr>
+      <a:endParaRPr lang="en-US"/>
+    </a:p>
+  </c:txPr>
+  <c:externalData r:id="rId1">
+    <c:autoUpdate val="0"/>
+  </c:externalData>
+</c:chartSpace>
+</file>
+
 <file path=ppt/notesMasters/notesMaster1.xml><?xml version="1.0" encoding="utf-8"?>
 <p:notesMaster xmlns:a="http://schemas.openxmlformats.org/drawingml/2006/main" xmlns:p="http://schemas.openxmlformats.org/presentationml/2006/main" xmlns:r="http://schemas.openxmlformats.org/officeDocument/2006/relationships">
   <p:cSld>
@@ -949,7 +1209,7 @@
           <a:lstStyle/>
           <a:p>
             <a:r>
-              <a:t>Welcome. Today I'll show you the Agentic AI capability we have built into CostVision. In one sentence: the tool no longer just calculates — it learns from every analysis we run, remembers every part, gets more accurate with every real quote we log, and even works unattended, flagging savings opportunities by itself. Everything I'll show is from live runs of the system, not mock-ups.</a:t>
+              <a:t>Open strong, then pause. "Every costing tool on the market does maths. Ours does something none of them do — it learns." Hold up the idea: the tool remembers every part we've ever costed, recognises the next one, corrects itself against real quotes, and goes hunting for savings while nobody's watching. One promise before we start: every single number in this deck is from a live run of the real system — no mock-ups, no slideware. Let's go.</a:t>
             </a:r>
           </a:p>
         </p:txBody>
@@ -1019,7 +1279,7 @@
           <a:lstStyle/>
           <a:p>
             <a:r>
-              <a:t>The learning loop is the headline, but it sits on a wider AI platform we've built. The assistant answers from our own rate data with citations. The RFQ analyst turns a full quote package into a costed, risk-flagged negotiation brief. CAD feature costing tells designers which specific features drive cost. And carbon co-costing gives a CO2 figure alongside every price — which customers increasingly require. All of this feeds and benefits from the same knowledge base.</a:t>
+              <a:t>The learning loop is the headline, but it stands on a real platform. The assistant answers from our own rate data with citations — it quotes our numbers, it doesn't improvise. The RFQ analyst turns a full quote package into a costed, risk-flagged negotiation brief. CAD feature costing shows a designer which hole or surface is driving the price. And carbon co-costing puts a CO2 figure next to every pound — which automotive and aerospace customers now demand in the RFQ itself. Eighteen commodity engines, CAD-to-cost, PCB photo-to-BOM — and the agentic layer sits on top of all of it, feeding and fed by the same memory.</a:t>
             </a:r>
           </a:p>
         </p:txBody>
@@ -1089,7 +1349,7 @@
           <a:lstStyle/>
           <a:p>
             <a:r>
-              <a:t>A fair management question: what does this demand from the team? Honestly — almost nothing. Engineers keep costing parts exactly as they do today; the memory builds itself. The one new habit is a single click when a real supplier quote arrives. Optionally, attaching CAD or BOM files sharpens the matching, and a one-off import of historical quotes would let the system start smart instead of starting empty — that's my recommended first action if we proceed.</a:t>
+              <a:t>Fair management question: what does this cost the team in effort? Honestly — almost nothing. Engineers keep costing parts exactly as they do now; the memory builds itself in the background. The one new habit is a single click when a real quote arrives. Two optional accelerants: attach CAD or BOM files for sharper matching, and — my recommended first move — a one-off import of our historical quotes so the system starts SMART instead of empty. Low effort in, compounding value out. That's the whole ask on the input side.</a:t>
             </a:r>
           </a:p>
         </p:txBody>
@@ -1159,7 +1419,7 @@
           <a:lstStyle/>
           <a:p>
             <a:r>
-              <a:t>Everything on this slide was measured on the running system — live server, real database — not projected. The two headline accuracy results: after learning from three quotes, segment error dropped to well under one percent in both directions of bias. The confidence band tightened seven-fold. Recognition worked at 99 percent on the live example. The unattended agent surfaced half a million pounds. And the whole capability is protected by 813 automated tests, so it won't quietly regress. One caveat I want to be transparent about: these demos used small seeded datasets — real-world accuracy will build as OUR data accumulates. The mechanism is proven; the asset grows with use.</a:t>
+              <a:t>Everything on this slide was measured on the running system — live server, real database, real API calls — not projected. Segment error dropped to well under one percent in BOTH directions of bias. The confidence band tightened seven-fold. Recognition hit ninety-nine percent on the live example. The unattended agent surfaced half a million pounds. And nine hundred and seventeen tests stand guard so none of it quietly regresses. One honest caveat, because credibility is the whole game here: these demos ran on small seeded datasets — real-world accuracy builds as OUR data accumulates. The mechanism is proven. The asset grows with use.</a:t>
             </a:r>
           </a:p>
         </p:txBody>
@@ -1229,7 +1489,7 @@
           <a:lstStyle/>
           <a:p>
             <a:r>
-              <a:t>Four benefits worth remembering. Speed — new parts start from history, not from zero. Accuracy — it compounds with every quote and is always measured, which is what makes our numbers defensible with suppliers. Retention — expert judgement becomes company data instead of leaving with people. And proactive savings — the agent finds money continuously, quantified per year. Finally, the strategic point: this knowledge base is proprietary. A competitor can buy the same software; they cannot buy our accumulated costing intelligence.</a:t>
+              <a:t>Four benefits, business language. Speed: new parts start from proven history, not a blank sheet. Accuracy: it compounds with every quote and it's always measured — which is precisely what makes our numbers defensible with suppliers. Retention: your best engineers' judgement becomes company data instead of leaving in a leaver's head. And proactive savings: the agent finds money continuously, quantified per year. Then the strategic kicker — a competitor can buy the same software tomorrow. They cannot buy our accumulated costing intelligence. That's the moat, and it deepens every day.</a:t>
             </a:r>
           </a:p>
         </p:txBody>
@@ -1299,7 +1559,7 @@
           <a:lstStyle/>
           <a:p>
             <a:r>
-              <a:t>A new capability that sharpens the moat. Every should-cost now shows two ranges. On the left, the physics prior — a Monte-Carlo band that reflects how well the inputs are known; it's always available. On the right, the new one: an empirical band computed from the actual quotes you've logged, using a statistical method called conformal prediction that comes with a coverage guarantee. So instead of asserting a precision, the tool says, honestly, '90% of your real quotes for this material family have landed within plus-or-minus 6.5%.' That band edge is an observed error, not a claim — which is exactly why a buyer can defend it in the room. And it tightens on its own as more quotes are logged. No competitor states uncertainty with a guarantee like this.</a:t>
+              <a:t>New this year, and it sharpens the moat. Every should-cost now carries TWO ranges. On the left, the physics prior — a Monte-Carlo band reflecting how well the inputs are known; always available, every part. On the right, the new one: an empirical band built from the actual quotes you've logged, using conformal prediction — a method that comes with a mathematical coverage guarantee. So the tool stops asserting a precision and starts stating an observed fact: 'ninety percent of your real quotes for this family landed within plus-or-minus six-and-a-half percent.' That band edge is measured error, not a claim — which is exactly why a buyer can defend it in the room. And it tightens on its own. No competitor states uncertainty with a guarantee like this.</a:t>
             </a:r>
           </a:p>
         </p:txBody>
@@ -1369,7 +1629,7 @@
           <a:lstStyle/>
           <a:p>
             <a:r>
-              <a:t>This is a genuine closed loop on the autonomous agent. Until now it ranked findings by the size of the gap times the volume — the theoretical money. Now it learns which findings actually convert. Look at the table: the cast housing has a two-hundred-thousand-pound gap, but in our data casting renegotiations almost never close — a twenty percent hit rate — so the expected realizable value is forty thousand. The machined knuckle has half the raw gap, but machining renegotiations usually close — eighty percent — so its realizable value is eighty thousand. The agent now ranks the machining finding first, even though its headline number is smaller. Why does that help? Sourcing time is scarce; the agent points it at money you can actually recover, and it tracks pounds truly saved so the tool proves its own worth. Every closed negotiation teaches it with one click.</a:t>
+              <a:t>This closes the loop on the agent. It used to rank findings by the raw gap — the theoretical money. Now it learns which findings actually convert into cash. Watch the table: the cast housing shows a two-hundred-thousand-pound gap, but in our data casting renegotiations almost never close — twenty percent — so the realizable value is forty thousand. The machined knuckle has HALF the raw gap, but machining usually closes — eighty percent — so it's worth eighty thousand realizable. The agent now ranks the machining finding ABOVE the bigger one. Why does that matter? Sourcing time is scarce — it now points at money you can actually get, and tracks the pounds truly saved so the tool proves its own worth. It stopped shouting about theoretical money.</a:t>
             </a:r>
           </a:p>
         </p:txBody>
@@ -1439,7 +1699,7 @@
           <a:lstStyle/>
           <a:p>
             <a:r>
-              <a:t>This is the capability that turns a number into leverage. The tool now builds a small causal model of the part: it knows the material bucket is driven by a specific commodity index — aluminium here — and it computes, through the very same overhead and margin maths the engine already uses, how sensitive the price is. Then it writes the argument for you. Read the live example: material is eight-thirty-nine, driven by aluminium; every one percent move in aluminium shifts the piece price by eleven pence; and a supplier quote of ninety-five is only justified if aluminium were about fourteen percent above today's index — so ask them to prove that, or hold at eighty-six thirty-four. That is a defensible, arithmetic counter a buyer can say out loud. It converts should-cost into negotiating power — the number AND the sentence to win with it.</a:t>
+              <a:t>This is where a number becomes leverage. The tool now builds a small causal model of the part — it knows the material bucket is driven by a specific commodity index, aluminium here — and it runs the same overhead-and-margin maths the engine already uses to work out how sensitive the price is. Then it writes the argument for you. Read the live output: material is eight-thirty-nine, driven by aluminium; every one-percent move in the index shifts the piece price by eleven pence; a quote of ninety-five is only justified if aluminium were about fourteen percent above today — so ask them to prove it, or hold at eighty-six thirty-four. That's a sentence a buyer can say out loud and not get argued out of. Should-cost, converted into negotiating power — the number AND the words.</a:t>
             </a:r>
           </a:p>
         </p:txBody>
@@ -1509,7 +1769,7 @@
           <a:lstStyle/>
           <a:p>
             <a:r>
-              <a:t>Two ways to ask 'what if a commodity moves?' On the left, for a single part: drag a slider from minus twenty to plus twenty percent and the piece price recomputes live as you move it — plus fifteen percent aluminium takes this part from eighty-six thirty-four to eighty-seven ninety-two. On the right, for the whole portfolio: apply a move across every part at once and see who changes status — if steel rises ten percent, these seven parts flip underwater and here's the money at risk. That lets sourcing pre-empt losses instead of reacting to them. And the honest framing that keeps it credible: this is always a conditional — IF the index moves — never a forecast we can't defend. The day we connect a live market feed, the same machinery becomes a genuine forecast.</a:t>
+              <a:t>Two ways to ask 'what if a commodity moves?' Left, one part: drag a slider from minus twenty to plus twenty percent and the price recomputes live under your finger — plus fifteen percent aluminium takes this part from eighty-six thirty-four to eighty-seven ninety-two. Right, the whole portfolio at once: push a move across every part and watch who changes status — steel up ten percent, seven parts flip underwater, here's the money at risk. That's sourcing getting ahead of the market instead of reacting to it. And the framing that keeps it honest: it's always a conditional — IF the index moves — never a forecast we can't stand behind. Connect a live market feed and the same machinery becomes a real forecast overnight.</a:t>
             </a:r>
           </a:p>
         </p:txBody>
@@ -1579,7 +1839,7 @@
           <a:lstStyle/>
           <a:p>
             <a:r>
-              <a:t>The one slide that says why this beats what's on the market. The competitors demo continuous learning and adaptive reasoning, but they do it as a black box — a number you're told to trust. Our principle is the opposite, and it's the harder thing to build: every learned or derived number stays auditable. The bias factor, the conformal band, the hit-rate, the coach's arithmetic — all of it is a value a cost engineer can read and defend in a negotiation. The AI narrates and explains; it never decides the price in secret. So we match them on learning, autonomy and causal reasoning — and beat them on the one thing that actually wins deals in this field: defensibility. And it all runs inside our own walls, so the intelligence is our IP and never leaves the building. That combination — autonomous, self-improving, AND glass-box, on-premise — is not available anywhere else.</a:t>
+              <a:t>Now the feature I'm proudest of this year. Photograph a circuit board, and in about sixty seconds you get a costed bill of materials. The story here is honesty about the journey: it started as a clever demo, and complex automotive boards would sometimes come back EMPTY — a lot of compute, no result. We fixed that at the root, then hardened the whole pipeline. The chart is the proof: the same real ECU, costed by an engineer bottom-up in half a day versus the AI from one photo — sixty-nine pounds against seventy-three, within about five percent, in sixty seconds. On the right, the five fixes that got us there — grounding prices to a real catalogue, capping any part the model misreads so one bad line can't blow up the total, making fabrication deterministic, and splitting the headline into what you can trust versus what to verify. Bottom line: the two-to-three-times over-costing is gone. Same photo, same answer, every run — and it tells you exactly which lines to firm up before you quote.</a:t>
             </a:r>
           </a:p>
         </p:txBody>
@@ -1649,7 +1909,7 @@
           <a:lstStyle/>
           <a:p>
             <a:r>
-              <a:t>To close: the capability is built, tested and live — at no extra licence cost, running on our own infrastructure. I'll be honest about the one dependency: the intelligence starts empty and grows with use. So the ask is three small decisions. One: make logging the actual quote a one-click habit. Two: approve a one-off import of our historical quotes so the system starts smart — roughly a day or two of effort. Three: put the agent's findings on the sourcing agenda each month. If we do those three things, this becomes a compounding asset from day one. Thank you — happy to take questions or show the live system.</a:t>
+              <a:t>If you take one competitive message away, take this. Rivals can demo continuous learning and adaptive reasoning — but as a black box, a number you're told to trust. Our principle is the opposite, and it's the harder thing to build: every learned or derived value stays auditable. The bias factor, the conformal band, the hit-rate, the coach's arithmetic — all of it is a value a cost engineer can read and defend across the table. The AI narrates and explains; it never sets the price in secret. So we match the market on learning, autonomy and causal reasoning — and we beat it on the one thing that actually wins deals in this business: defensibility. Autonomous, self-improving, glass-box, AND on-premise so the intelligence never leaves our walls. That combination doesn't exist anywhere else.</a:t>
             </a:r>
           </a:p>
         </p:txBody>
@@ -1719,7 +1979,77 @@
           <a:lstStyle/>
           <a:p>
             <a:r>
-              <a:t>Four headline numbers, all verified. One: after learning from only three real quotes, the estimating error in a segment dropped from about 11% to under 1%. Two: the autonomous monitor found half a million pounds a year of pricing issues in our demonstration, entirely unattended. Three: when we costed a new bracket, the tool recognised three similar past parts at 99% similarity and told us why. Four: this is production-grade — 813 automated tests. The key message: costing knowledge now accumulates as a company asset instead of living in individual experts' heads.</a:t>
+              <a:t>If you remember four numbers, remember these. Error fell thirty-six-fold — eleven percent down to under one — after the tool learned from just three real quotes. The background agent found half a million pounds a year of pricing issues with nobody at the keyboard. It recognised a brand-new bracket against past parts at ninety-nine percent and told us why. And it's production-grade — nine hundred and seventeen automated tests. But here's the one line that matters: costing intelligence used to live in people's heads and walk out the door when they left. Now it accumulates as a company asset that gets more valuable every day we use it.</a:t>
+            </a:r>
+          </a:p>
+        </p:txBody>
+      </p:sp>
+      <p:sp>
+        <p:nvSpPr>
+          <p:cNvPr id="4" name="Slide Number Placeholder 3"/>
+          <p:cNvSpPr>
+            <a:spLocks noGrp="1"/>
+          </p:cNvSpPr>
+          <p:nvPr>
+            <p:ph type="sldNum" idx="5" sz="quarter"/>
+          </p:nvPr>
+        </p:nvSpPr>
+        <p:spPr/>
+      </p:sp>
+    </p:spTree>
+  </p:cSld>
+  <p:clrMapOvr>
+    <a:masterClrMapping/>
+  </p:clrMapOvr>
+</p:notes>
+</file>
+
+<file path=ppt/notesSlides/notesSlide20.xml><?xml version="1.0" encoding="utf-8"?>
+<p:notes xmlns:a="http://schemas.openxmlformats.org/drawingml/2006/main" xmlns:p="http://schemas.openxmlformats.org/presentationml/2006/main" xmlns:r="http://schemas.openxmlformats.org/officeDocument/2006/relationships">
+  <p:cSld>
+    <p:spTree>
+      <p:nvGrpSpPr>
+        <p:cNvPr id="1" name=""/>
+        <p:cNvGrpSpPr/>
+        <p:nvPr/>
+      </p:nvGrpSpPr>
+      <p:grpSpPr>
+        <a:xfrm>
+          <a:off x="0" y="0"/>
+          <a:ext cx="0" cy="0"/>
+          <a:chOff x="0" y="0"/>
+          <a:chExt cx="0" cy="0"/>
+        </a:xfrm>
+      </p:grpSpPr>
+      <p:sp>
+        <p:nvSpPr>
+          <p:cNvPr id="2" name="Slide Image Placeholder 1"/>
+          <p:cNvSpPr>
+            <a:spLocks noGrp="1"/>
+          </p:cNvSpPr>
+          <p:nvPr>
+            <p:ph type="sldImg" idx="2"/>
+          </p:nvPr>
+        </p:nvSpPr>
+        <p:spPr/>
+      </p:sp>
+      <p:sp>
+        <p:nvSpPr>
+          <p:cNvPr id="3" name="Notes Placeholder 2"/>
+          <p:cNvSpPr>
+            <a:spLocks noGrp="1"/>
+          </p:cNvSpPr>
+          <p:nvPr>
+            <p:ph type="body" idx="3" sz="quarter"/>
+          </p:nvPr>
+        </p:nvSpPr>
+        <p:spPr/>
+        <p:txBody>
+          <a:bodyPr/>
+          <a:lstStyle/>
+          <a:p>
+            <a:r>
+              <a:t>To close. The capability is built, tested — nine hundred and seventeen tests — and live, at no extra licence cost, running on our own infrastructure. I'll be straight about the one dependency: the intelligence starts empty and grows with use. So the ask is three small decisions. One: make 'Log Actual £' a one-click habit when quotes come in. Two: approve a one-off import of our historical quotes so the system starts smart — a day or two of effort. Three: put the agent's findings on the sourcing agenda each month; it's already finding money. Do those three things and this becomes a compounding asset from day one. Thank you — I'm happy to take questions, or show you the live system right now.</a:t>
             </a:r>
           </a:p>
         </p:txBody>
@@ -1789,7 +2119,7 @@
           <a:lstStyle/>
           <a:p>
             <a:r>
-              <a:t>When we say Agentic AI, we mean four concrete abilities. It REMEMBERS — every analysis becomes a stored case. It RECOGNISES — new parts are matched against that memory. It SELF-CORRECTS — real quotes teach it, and its accuracy is measured, not asserted. And it ACTS — a background agent raises findings without being asked. One important design choice: every AI suggestion is traceable to specific past parts and shows its arithmetic. That auditability is what makes it usable in supplier negotiations.</a:t>
+              <a:t>"Agentic" gets thrown around a lot, so let me make it concrete — four plain verbs. It REMEMBERS: every analysis becomes a stored case. It RECOGNISES: new parts get matched to that memory instantly. It SELF-CORRECTS: real quotes teach it, and its accuracy is measured, not claimed. And it ACTS: an agent raises findings without being asked. One design choice underpins all of it — every suggestion shows its source parts and its arithmetic. That's deliberate, because a number you can't defend is worthless in a supplier negotiation. Ours you can defend, line by line.</a:t>
             </a:r>
           </a:p>
         </p:txBody>
@@ -1859,7 +2189,7 @@
           <a:lstStyle/>
           <a:p>
             <a:r>
-              <a:t>This is the whole system on one slide. The engineer works exactly as before — they cost a part. The tool remembers it, recognises similar history, and makes suggestions, all automatically. When a real supplier quote arrives, one click teaches the tool, and the background agent keeps watch from then on. The crucial point for adoption: there is essentially no extra workload. One new click when a quote arrives.</a:t>
+              <a:t>Here's the whole machine on one slide — and the punchline is how little it asks of the engineer. They cost a part exactly as they do today. Everything blue and automatic happens on its own: it remembers, it recognises, it suggests, and the agent keeps watch. There is exactly ONE new habit — a single click, 'Log Actual £,' when a real quote lands. That one click is the fuel for every loop on this slide, and every loop makes the next estimate sharper. No new workload, compounding returns. That's the deal.</a:t>
             </a:r>
           </a:p>
         </p:txBody>
@@ -1929,7 +2259,7 @@
           <a:lstStyle/>
           <a:p>
             <a:r>
-              <a:t>Capability one: the memory. Every analysis is saved with a fingerprint of the part, the full result, any real quotes, and — importantly — the places where an expert corrected the AI. Corrections are how our experts literally teach the tool. Right side: this is shared across the team, it lives in our own database on our own servers, and it compounds — it becomes genuinely useful after only twenty to thirty analyses. Every costing we run from today is a deposit into this asset.</a:t>
+              <a:t>Capability one — the memory. For every analysis we keep a fingerprint of the part, the full costed result, any real quotes, and — this is the clever bit — the exact places an expert overrode the AI. Those corrections are our engineers literally teaching the tool. On the right is why it matters to us specifically: it's shared, so a junior inherits senior judgement on day one; it lives on our servers, so it's our asset, not a vendor's; and it compounds — genuinely useful after only twenty or thirty analyses. Every costing we run from today is a deposit into an account that only grows.</a:t>
             </a:r>
           </a:p>
         </p:txBody>
@@ -1999,7 +2329,7 @@
           <a:lstStyle/>
           <a:p>
             <a:r>
-              <a:t>Capability two, shown with the actual live output. An engineer starts costing a new bracket. Before they finish, the tool has found the three most similar parts we've costed before — at 98 to 99 percent similarity — and it explains WHY they matched: same material family, same weight class, same region. It then suggests: the median cost of those parts, the material they all used, and crucially the real quoted prices we logged. A junior engineer instantly benefits from all previous work. And note — every number names its source. No black box.</a:t>
+              <a:t>Capability two, shown with the tool's actual live output. An engineer starts a new aluminium bracket. Before they've even finished, the tool has surfaced the three most similar parts we've ever costed — at ninety-eight to ninety-nine percent — and it tells you WHY they matched: same material family, same weight class, same region. Then it hands over the gold: the median cost, the shared material, and the real prices we actually paid. A junior just stood on the shoulders of every senior who came before them. And notice — every number names its source. Nothing here is a black box.</a:t>
             </a:r>
           </a:p>
         </p:txBody>
@@ -2069,7 +2399,7 @@
           <a:lstStyle/>
           <a:p>
             <a:r>
-              <a:t>Capability three is the accuracy engine. The chart shows a real measured result: in machining, our estimates ran about 11 percent below the real prices. After the tool learned from just three logged quotes, the remaining error was 0.3 percent. Same story for castings from China, where the bias was in the opposite direction. And that's the subtle but important point on the right: one category under-estimates, another over-estimates — a portfolio average hides both. The tool corrects each category separately. Accuracy here is measured against reality and reported openly — not a marketing claim.</a:t>
+              <a:t>Capability three is the accuracy engine, and this is a real measured result. Our machining estimates ran about eleven percent LOW against real prices. After the tool learned from three logged quotes, the error was three-tenths of a percent. Now look right — and this is the subtle, important part. Machining ran low; our China castings ran high. Average them together and everything looks 'fine' — the errors cancel and hide. The tool refuses to average. It corrects each process, material and region separately, so it catches exactly what a portfolio average conceals. Accuracy here is measured against reality and reported out loud — not asserted on a slide.</a:t>
             </a:r>
           </a:p>
         </p:txBody>
@@ -2139,7 +2469,7 @@
           <a:lstStyle/>
           <a:p>
             <a:r>
-              <a:t>Capability four: honesty about precision. Every estimate is now delivered as a range — optimistic, most likely, conservative. Early on, with no evidence, the range is wide, and that's the truth. As real quotes prove the tool's accuracy, the range tightens automatically — on our test part, from plus-or-minus twenty percent down to three percent. For buyers this is a practical negotiation tool: the conservative end is the walk-away price; the optimistic end is the stretch target.</a:t>
+              <a:t>Capability four — honesty about precision, which is a feature, not a weakness. Every estimate now comes as a range: optimistic, most likely, conservative. Early on, with no evidence, that range is wide — and that IS the truth. As real quotes prove the tool right, the range tightens on its own: on our test part, from plus-or-minus twenty percent down to three. Give a buyer this and you've handed them a script — the conservative end is the walk-away, the optimistic end is the stretch target. A single number pretends to a confidence early estimates simply don't have. This tells the truth, and the truth negotiates better.</a:t>
             </a:r>
           </a:p>
         </p:txBody>
@@ -2209,7 +2539,7 @@
           <a:lstStyle/>
           <a:p>
             <a:r>
-              <a:t>Capability five is the one that makes this genuinely 'agentic'. A monitor runs on the server on a schedule — first pass thirty seconds after start-up, then every few hours. It compares what we PAY with what things SHOULD cost, using everything the tool has learned. In the live demonstration it opened these three findings by itself: a renegotiation opportunity worth four hundred thousand pounds a year, an underwater price that signals supply risk, and a stale estimate that needs revalidating. Half a million pounds a year surfaced with nobody at the keyboard. Each finding shows its arithmetic — ready to take into a supplier meeting.</a:t>
+              <a:t>Capability five — this is the one that earns the word 'agentic.' A monitor runs on our server on a schedule and compares what we PAY against what things SHOULD cost, using everything the tool has learned. In the live demo, with nobody at the keyboard, it opened three findings by itself: a renegotiation worth four hundred thousand a year, an 'underwater' price that flags supply risk, and a stale estimate that needs a fresh quote. Half a million pounds a year, surfaced unattended — and every finding shows its arithmetic, ready to carry straight into a supplier meeting. The tool isn't waiting to be asked anymore. It's already working.</a:t>
             </a:r>
           </a:p>
         </p:txBody>
@@ -9077,7 +9407,7 @@
                 </a:solidFill>
                 <a:latin typeface="Calibri"/>
               </a:rPr>
-              <a:t>790 passing (60 suites)</a:t>
+              <a:t>917 passing (77 suites)</a:t>
             </a:r>
           </a:p>
         </p:txBody>
@@ -14316,7 +14646,7 @@
                 </a:solidFill>
                 <a:latin typeface="Calibri"/>
               </a:rPr>
-              <a:t>THE DIFFERENTIATOR</a:t>
+              <a:t>NEW IN 2026 · ADVANCED INTELLIGENCE</a:t>
             </a:r>
           </a:p>
         </p:txBody>
@@ -14358,25 +14688,699 @@
                 </a:solidFill>
                 <a:latin typeface="Calibri"/>
               </a:rPr>
-              <a:t>Why ours is different — glass-box autonomy</a:t>
-            </a:r>
-          </a:p>
-        </p:txBody>
-      </p:sp>
-      <p:sp>
-        <p:nvSpPr>
-          <p:cNvPr id="9" name="Rounded Rectangle 8"/>
+              <a:t>PCB photo → BOM → should-cost — now supplier-grade</a:t>
+            </a:r>
+          </a:p>
+        </p:txBody>
+      </p:sp>
+      <p:sp>
+        <p:nvSpPr>
+          <p:cNvPr id="9" name="TextBox 8"/>
+          <p:cNvSpPr txBox="1"/>
+          <p:nvPr/>
+        </p:nvSpPr>
+        <p:spPr>
+          <a:xfrm>
+            <a:off x="411480" y="1664208"/>
+            <a:ext cx="11338560" cy="384048"/>
+          </a:xfrm>
+          <a:prstGeom prst="rect">
+            <a:avLst/>
+          </a:prstGeom>
+          <a:noFill/>
+        </p:spPr>
+        <p:txBody>
+          <a:bodyPr wrap="square" anchor="t" lIns="0" rIns="0" tIns="0" bIns="0">
+            <a:spAutoFit/>
+          </a:bodyPr>
+          <a:lstStyle/>
+          <a:p>
+            <a:pPr algn="l">
+              <a:lnSpc>
+                <a:spcPct val="100000"/>
+              </a:lnSpc>
+              <a:spcAft>
+                <a:spcPts val="400"/>
+              </a:spcAft>
+            </a:pPr>
+            <a:r>
+              <a:rPr sz="1300" b="0" i="0">
+                <a:solidFill>
+                  <a:srgbClr val="334155"/>
+                </a:solidFill>
+                <a:latin typeface="Calibri"/>
+              </a:rPr>
+              <a:t>Photograph a circuit board, get a costed bill of materials in ~60 seconds. This year we hardened it from a clever demo into a </a:t>
+            </a:r>
+            <a:r>
+              <a:rPr sz="1300" b="1" i="0">
+                <a:solidFill>
+                  <a:srgbClr val="0F172A"/>
+                </a:solidFill>
+                <a:latin typeface="Calibri"/>
+              </a:rPr>
+              <a:t>number you can put in front of a supplier.</a:t>
+            </a:r>
+          </a:p>
+        </p:txBody>
+      </p:sp>
+      <p:graphicFrame>
+        <p:nvGraphicFramePr>
+          <p:cNvPr id="10" name="Chart 9"/>
+          <p:cNvGraphicFramePr>
+            <a:graphicFrameLocks noGrp="1"/>
+          </p:cNvGraphicFramePr>
+          <p:nvPr/>
+        </p:nvGraphicFramePr>
+        <p:xfrm>
+          <a:off x="411480" y="2240280"/>
+          <a:ext cx="5623560" cy="3063240"/>
+        </p:xfrm>
+        <a:graphic>
+          <a:graphicData uri="http://schemas.openxmlformats.org/drawingml/2006/chart">
+            <c:chart xmlns:c="http://schemas.openxmlformats.org/drawingml/2006/chart" r:id="rId2"/>
+          </a:graphicData>
+        </a:graphic>
+      </p:graphicFrame>
+      <p:sp>
+        <p:nvSpPr>
+          <p:cNvPr id="11" name="TextBox 10"/>
+          <p:cNvSpPr txBox="1"/>
+          <p:nvPr/>
+        </p:nvSpPr>
+        <p:spPr>
+          <a:xfrm>
+            <a:off x="411480" y="5321808"/>
+            <a:ext cx="5623560" cy="384048"/>
+          </a:xfrm>
+          <a:prstGeom prst="rect">
+            <a:avLst/>
+          </a:prstGeom>
+          <a:noFill/>
+        </p:spPr>
+        <p:txBody>
+          <a:bodyPr wrap="square" anchor="t" lIns="0" rIns="0" tIns="0" bIns="0">
+            <a:spAutoFit/>
+          </a:bodyPr>
+          <a:lstStyle/>
+          <a:p>
+            <a:pPr algn="l">
+              <a:lnSpc>
+                <a:spcPct val="105000"/>
+              </a:lnSpc>
+              <a:spcAft>
+                <a:spcPts val="400"/>
+              </a:spcAft>
+            </a:pPr>
+            <a:r>
+              <a:rPr sz="1000" b="0" i="1">
+                <a:solidFill>
+                  <a:srgbClr val="64748B"/>
+                </a:solidFill>
+                <a:latin typeface="Calibri"/>
+              </a:rPr>
+              <a:t>Real automotive ECU, China @ 10k/yr — AI landed within ~5% of a half-day manual estimate, in ~60 s.</a:t>
+            </a:r>
+          </a:p>
+        </p:txBody>
+      </p:sp>
+      <p:sp>
+        <p:nvSpPr>
+          <p:cNvPr id="12" name="Rounded Rectangle 11"/>
           <p:cNvSpPr/>
           <p:nvPr/>
         </p:nvSpPr>
         <p:spPr>
           <a:xfrm>
-            <a:off x="411480" y="1828800"/>
-            <a:ext cx="11384280" cy="1188720"/>
+            <a:off x="6263640" y="2240280"/>
+            <a:ext cx="5532120" cy="3063240"/>
           </a:xfrm>
           <a:prstGeom prst="roundRect">
             <a:avLst>
-              <a:gd name="adj" fmla="val 6000"/>
+              <a:gd name="adj" fmla="val 5000"/>
+            </a:avLst>
+          </a:prstGeom>
+          <a:solidFill>
+            <a:srgbClr val="F1F5F9"/>
+          </a:solidFill>
+          <a:ln>
+            <a:noFill/>
+          </a:ln>
+          <a:effectLst/>
+        </p:spPr>
+        <p:style>
+          <a:lnRef idx="1">
+            <a:schemeClr val="accent1"/>
+          </a:lnRef>
+          <a:fillRef idx="3">
+            <a:schemeClr val="accent1"/>
+          </a:fillRef>
+          <a:effectRef idx="2">
+            <a:schemeClr val="accent1"/>
+          </a:effectRef>
+          <a:fontRef idx="minor">
+            <a:schemeClr val="lt1"/>
+          </a:fontRef>
+        </p:style>
+        <p:txBody>
+          <a:bodyPr rtlCol="0" anchor="ctr"/>
+          <a:lstStyle/>
+          <a:p>
+            <a:pPr algn="ctr"/>
+          </a:p>
+        </p:txBody>
+      </p:sp>
+      <p:sp>
+        <p:nvSpPr>
+          <p:cNvPr id="13" name="TextBox 12"/>
+          <p:cNvSpPr txBox="1"/>
+          <p:nvPr/>
+        </p:nvSpPr>
+        <p:spPr>
+          <a:xfrm>
+            <a:off x="6537960" y="2395728"/>
+            <a:ext cx="5029200" cy="320040"/>
+          </a:xfrm>
+          <a:prstGeom prst="rect">
+            <a:avLst/>
+          </a:prstGeom>
+          <a:noFill/>
+        </p:spPr>
+        <p:txBody>
+          <a:bodyPr wrap="square" anchor="t" lIns="0" rIns="0" tIns="0" bIns="0">
+            <a:spAutoFit/>
+          </a:bodyPr>
+          <a:lstStyle/>
+          <a:p>
+            <a:pPr algn="l">
+              <a:lnSpc>
+                <a:spcPct val="100000"/>
+              </a:lnSpc>
+              <a:spcAft>
+                <a:spcPts val="400"/>
+              </a:spcAft>
+            </a:pPr>
+            <a:r>
+              <a:rPr sz="1400" b="1" i="0">
+                <a:solidFill>
+                  <a:srgbClr val="0F172A"/>
+                </a:solidFill>
+                <a:latin typeface="Calibri"/>
+              </a:rPr>
+              <a:t>What we fixed this year</a:t>
+            </a:r>
+          </a:p>
+        </p:txBody>
+      </p:sp>
+      <p:sp>
+        <p:nvSpPr>
+          <p:cNvPr id="14" name="Rectangle 13"/>
+          <p:cNvSpPr/>
+          <p:nvPr/>
+        </p:nvSpPr>
+        <p:spPr>
+          <a:xfrm>
+            <a:off x="6537960" y="2834640"/>
+            <a:ext cx="82296" cy="384048"/>
+          </a:xfrm>
+          <a:prstGeom prst="rect">
+            <a:avLst/>
+          </a:prstGeom>
+          <a:solidFill>
+            <a:srgbClr val="059669"/>
+          </a:solidFill>
+          <a:ln>
+            <a:noFill/>
+          </a:ln>
+          <a:effectLst/>
+        </p:spPr>
+        <p:style>
+          <a:lnRef idx="1">
+            <a:schemeClr val="accent1"/>
+          </a:lnRef>
+          <a:fillRef idx="3">
+            <a:schemeClr val="accent1"/>
+          </a:fillRef>
+          <a:effectRef idx="2">
+            <a:schemeClr val="accent1"/>
+          </a:effectRef>
+          <a:fontRef idx="minor">
+            <a:schemeClr val="lt1"/>
+          </a:fontRef>
+        </p:style>
+        <p:txBody>
+          <a:bodyPr rtlCol="0" anchor="ctr"/>
+          <a:lstStyle/>
+          <a:p>
+            <a:pPr algn="ctr"/>
+          </a:p>
+        </p:txBody>
+      </p:sp>
+      <p:sp>
+        <p:nvSpPr>
+          <p:cNvPr id="15" name="TextBox 14"/>
+          <p:cNvSpPr txBox="1"/>
+          <p:nvPr/>
+        </p:nvSpPr>
+        <p:spPr>
+          <a:xfrm>
+            <a:off x="6784848" y="2788920"/>
+            <a:ext cx="4892040" cy="502920"/>
+          </a:xfrm>
+          <a:prstGeom prst="rect">
+            <a:avLst/>
+          </a:prstGeom>
+          <a:noFill/>
+        </p:spPr>
+        <p:txBody>
+          <a:bodyPr wrap="square" anchor="t" lIns="0" rIns="0" tIns="0" bIns="0">
+            <a:spAutoFit/>
+          </a:bodyPr>
+          <a:lstStyle/>
+          <a:p>
+            <a:pPr algn="l">
+              <a:lnSpc>
+                <a:spcPct val="100000"/>
+              </a:lnSpc>
+              <a:spcAft>
+                <a:spcPts val="400"/>
+              </a:spcAft>
+            </a:pPr>
+            <a:r>
+              <a:rPr sz="1150" b="1" i="0">
+                <a:solidFill>
+                  <a:srgbClr val="0F172A"/>
+                </a:solidFill>
+                <a:latin typeface="Calibri"/>
+              </a:rPr>
+              <a:t>✓  Empty-BOM bug — killed — </a:t>
+            </a:r>
+            <a:r>
+              <a:rPr sz="1050" b="0" i="0">
+                <a:solidFill>
+                  <a:srgbClr val="334155"/>
+                </a:solidFill>
+                <a:latin typeface="Calibri"/>
+              </a:rPr>
+              <a:t>Complex boards used to return nothing; now we read every block the model emits.</a:t>
+            </a:r>
+          </a:p>
+        </p:txBody>
+      </p:sp>
+      <p:sp>
+        <p:nvSpPr>
+          <p:cNvPr id="16" name="Rectangle 15"/>
+          <p:cNvSpPr/>
+          <p:nvPr/>
+        </p:nvSpPr>
+        <p:spPr>
+          <a:xfrm>
+            <a:off x="6537960" y="3337559"/>
+            <a:ext cx="82296" cy="384048"/>
+          </a:xfrm>
+          <a:prstGeom prst="rect">
+            <a:avLst/>
+          </a:prstGeom>
+          <a:solidFill>
+            <a:srgbClr val="2563EB"/>
+          </a:solidFill>
+          <a:ln>
+            <a:noFill/>
+          </a:ln>
+          <a:effectLst/>
+        </p:spPr>
+        <p:style>
+          <a:lnRef idx="1">
+            <a:schemeClr val="accent1"/>
+          </a:lnRef>
+          <a:fillRef idx="3">
+            <a:schemeClr val="accent1"/>
+          </a:fillRef>
+          <a:effectRef idx="2">
+            <a:schemeClr val="accent1"/>
+          </a:effectRef>
+          <a:fontRef idx="minor">
+            <a:schemeClr val="lt1"/>
+          </a:fontRef>
+        </p:style>
+        <p:txBody>
+          <a:bodyPr rtlCol="0" anchor="ctr"/>
+          <a:lstStyle/>
+          <a:p>
+            <a:pPr algn="ctr"/>
+          </a:p>
+        </p:txBody>
+      </p:sp>
+      <p:sp>
+        <p:nvSpPr>
+          <p:cNvPr id="17" name="TextBox 16"/>
+          <p:cNvSpPr txBox="1"/>
+          <p:nvPr/>
+        </p:nvSpPr>
+        <p:spPr>
+          <a:xfrm>
+            <a:off x="6784848" y="3291839"/>
+            <a:ext cx="4892040" cy="502920"/>
+          </a:xfrm>
+          <a:prstGeom prst="rect">
+            <a:avLst/>
+          </a:prstGeom>
+          <a:noFill/>
+        </p:spPr>
+        <p:txBody>
+          <a:bodyPr wrap="square" anchor="t" lIns="0" rIns="0" tIns="0" bIns="0">
+            <a:spAutoFit/>
+          </a:bodyPr>
+          <a:lstStyle/>
+          <a:p>
+            <a:pPr algn="l">
+              <a:lnSpc>
+                <a:spcPct val="100000"/>
+              </a:lnSpc>
+              <a:spcAft>
+                <a:spcPts val="400"/>
+              </a:spcAft>
+            </a:pPr>
+            <a:r>
+              <a:rPr sz="1150" b="1" i="0">
+                <a:solidFill>
+                  <a:srgbClr val="0F172A"/>
+                </a:solidFill>
+                <a:latin typeface="Calibri"/>
+              </a:rPr>
+              <a:t>✓  Catalogue grounding — </a:t>
+            </a:r>
+            <a:r>
+              <a:rPr sz="1050" b="0" i="0">
+                <a:solidFill>
+                  <a:srgbClr val="334155"/>
+                </a:solidFill>
+                <a:latin typeface="Calibri"/>
+              </a:rPr>
+              <a:t>Confirmed parts snap to real market prices — offline, no external API.</a:t>
+            </a:r>
+          </a:p>
+        </p:txBody>
+      </p:sp>
+      <p:sp>
+        <p:nvSpPr>
+          <p:cNvPr id="18" name="Rectangle 17"/>
+          <p:cNvSpPr/>
+          <p:nvPr/>
+        </p:nvSpPr>
+        <p:spPr>
+          <a:xfrm>
+            <a:off x="6537960" y="3840480"/>
+            <a:ext cx="82296" cy="384048"/>
+          </a:xfrm>
+          <a:prstGeom prst="rect">
+            <a:avLst/>
+          </a:prstGeom>
+          <a:solidFill>
+            <a:srgbClr val="7C3AED"/>
+          </a:solidFill>
+          <a:ln>
+            <a:noFill/>
+          </a:ln>
+          <a:effectLst/>
+        </p:spPr>
+        <p:style>
+          <a:lnRef idx="1">
+            <a:schemeClr val="accent1"/>
+          </a:lnRef>
+          <a:fillRef idx="3">
+            <a:schemeClr val="accent1"/>
+          </a:fillRef>
+          <a:effectRef idx="2">
+            <a:schemeClr val="accent1"/>
+          </a:effectRef>
+          <a:fontRef idx="minor">
+            <a:schemeClr val="lt1"/>
+          </a:fontRef>
+        </p:style>
+        <p:txBody>
+          <a:bodyPr rtlCol="0" anchor="ctr"/>
+          <a:lstStyle/>
+          <a:p>
+            <a:pPr algn="ctr"/>
+          </a:p>
+        </p:txBody>
+      </p:sp>
+      <p:sp>
+        <p:nvSpPr>
+          <p:cNvPr id="19" name="TextBox 18"/>
+          <p:cNvSpPr txBox="1"/>
+          <p:nvPr/>
+        </p:nvSpPr>
+        <p:spPr>
+          <a:xfrm>
+            <a:off x="6784848" y="3794760"/>
+            <a:ext cx="4892040" cy="502920"/>
+          </a:xfrm>
+          <a:prstGeom prst="rect">
+            <a:avLst/>
+          </a:prstGeom>
+          <a:noFill/>
+        </p:spPr>
+        <p:txBody>
+          <a:bodyPr wrap="square" anchor="t" lIns="0" rIns="0" tIns="0" bIns="0">
+            <a:spAutoFit/>
+          </a:bodyPr>
+          <a:lstStyle/>
+          <a:p>
+            <a:pPr algn="l">
+              <a:lnSpc>
+                <a:spcPct val="100000"/>
+              </a:lnSpc>
+              <a:spcAft>
+                <a:spcPts val="400"/>
+              </a:spcAft>
+            </a:pPr>
+            <a:r>
+              <a:rPr sz="1150" b="1" i="0">
+                <a:solidFill>
+                  <a:srgbClr val="0F172A"/>
+                </a:solidFill>
+                <a:latin typeface="Calibri"/>
+              </a:rPr>
+              <a:t>✓  Class-median cap + magnitude guard — </a:t>
+            </a:r>
+            <a:r>
+              <a:rPr sz="1050" b="0" i="0">
+                <a:solidFill>
+                  <a:srgbClr val="334155"/>
+                </a:solidFill>
+                <a:latin typeface="Calibri"/>
+              </a:rPr>
+              <a:t>A misread part can no longer dominate: one MCU £84 → £18, capped &amp; flagged.</a:t>
+            </a:r>
+          </a:p>
+        </p:txBody>
+      </p:sp>
+      <p:sp>
+        <p:nvSpPr>
+          <p:cNvPr id="20" name="Rectangle 19"/>
+          <p:cNvSpPr/>
+          <p:nvPr/>
+        </p:nvSpPr>
+        <p:spPr>
+          <a:xfrm>
+            <a:off x="6537960" y="4343400"/>
+            <a:ext cx="82296" cy="384048"/>
+          </a:xfrm>
+          <a:prstGeom prst="rect">
+            <a:avLst/>
+          </a:prstGeom>
+          <a:solidFill>
+            <a:srgbClr val="0891B2"/>
+          </a:solidFill>
+          <a:ln>
+            <a:noFill/>
+          </a:ln>
+          <a:effectLst/>
+        </p:spPr>
+        <p:style>
+          <a:lnRef idx="1">
+            <a:schemeClr val="accent1"/>
+          </a:lnRef>
+          <a:fillRef idx="3">
+            <a:schemeClr val="accent1"/>
+          </a:fillRef>
+          <a:effectRef idx="2">
+            <a:schemeClr val="accent1"/>
+          </a:effectRef>
+          <a:fontRef idx="minor">
+            <a:schemeClr val="lt1"/>
+          </a:fontRef>
+        </p:style>
+        <p:txBody>
+          <a:bodyPr rtlCol="0" anchor="ctr"/>
+          <a:lstStyle/>
+          <a:p>
+            <a:pPr algn="ctr"/>
+          </a:p>
+        </p:txBody>
+      </p:sp>
+      <p:sp>
+        <p:nvSpPr>
+          <p:cNvPr id="21" name="TextBox 20"/>
+          <p:cNvSpPr txBox="1"/>
+          <p:nvPr/>
+        </p:nvSpPr>
+        <p:spPr>
+          <a:xfrm>
+            <a:off x="6784848" y="4297680"/>
+            <a:ext cx="4892040" cy="502920"/>
+          </a:xfrm>
+          <a:prstGeom prst="rect">
+            <a:avLst/>
+          </a:prstGeom>
+          <a:noFill/>
+        </p:spPr>
+        <p:txBody>
+          <a:bodyPr wrap="square" anchor="t" lIns="0" rIns="0" tIns="0" bIns="0">
+            <a:spAutoFit/>
+          </a:bodyPr>
+          <a:lstStyle/>
+          <a:p>
+            <a:pPr algn="l">
+              <a:lnSpc>
+                <a:spcPct val="100000"/>
+              </a:lnSpc>
+              <a:spcAft>
+                <a:spcPts val="400"/>
+              </a:spcAft>
+            </a:pPr>
+            <a:r>
+              <a:rPr sz="1150" b="1" i="0">
+                <a:solidFill>
+                  <a:srgbClr val="0F172A"/>
+                </a:solidFill>
+                <a:latin typeface="Calibri"/>
+              </a:rPr>
+              <a:t>✓  Deterministic fabrication — </a:t>
+            </a:r>
+            <a:r>
+              <a:rPr sz="1050" b="0" i="0">
+                <a:solidFill>
+                  <a:srgbClr val="334155"/>
+                </a:solidFill>
+                <a:latin typeface="Calibri"/>
+              </a:rPr>
+              <a:t>Fab is derived from stable board features — the headline no longer swings run-to-run.</a:t>
+            </a:r>
+          </a:p>
+        </p:txBody>
+      </p:sp>
+      <p:sp>
+        <p:nvSpPr>
+          <p:cNvPr id="22" name="Rectangle 21"/>
+          <p:cNvSpPr/>
+          <p:nvPr/>
+        </p:nvSpPr>
+        <p:spPr>
+          <a:xfrm>
+            <a:off x="6537960" y="4846320"/>
+            <a:ext cx="82296" cy="384048"/>
+          </a:xfrm>
+          <a:prstGeom prst="rect">
+            <a:avLst/>
+          </a:prstGeom>
+          <a:solidFill>
+            <a:srgbClr val="D97706"/>
+          </a:solidFill>
+          <a:ln>
+            <a:noFill/>
+          </a:ln>
+          <a:effectLst/>
+        </p:spPr>
+        <p:style>
+          <a:lnRef idx="1">
+            <a:schemeClr val="accent1"/>
+          </a:lnRef>
+          <a:fillRef idx="3">
+            <a:schemeClr val="accent1"/>
+          </a:fillRef>
+          <a:effectRef idx="2">
+            <a:schemeClr val="accent1"/>
+          </a:effectRef>
+          <a:fontRef idx="minor">
+            <a:schemeClr val="lt1"/>
+          </a:fontRef>
+        </p:style>
+        <p:txBody>
+          <a:bodyPr rtlCol="0" anchor="ctr"/>
+          <a:lstStyle/>
+          <a:p>
+            <a:pPr algn="ctr"/>
+          </a:p>
+        </p:txBody>
+      </p:sp>
+      <p:sp>
+        <p:nvSpPr>
+          <p:cNvPr id="23" name="TextBox 22"/>
+          <p:cNvSpPr txBox="1"/>
+          <p:nvPr/>
+        </p:nvSpPr>
+        <p:spPr>
+          <a:xfrm>
+            <a:off x="6784848" y="4800600"/>
+            <a:ext cx="4892040" cy="502920"/>
+          </a:xfrm>
+          <a:prstGeom prst="rect">
+            <a:avLst/>
+          </a:prstGeom>
+          <a:noFill/>
+        </p:spPr>
+        <p:txBody>
+          <a:bodyPr wrap="square" anchor="t" lIns="0" rIns="0" tIns="0" bIns="0">
+            <a:spAutoFit/>
+          </a:bodyPr>
+          <a:lstStyle/>
+          <a:p>
+            <a:pPr algn="l">
+              <a:lnSpc>
+                <a:spcPct val="100000"/>
+              </a:lnSpc>
+              <a:spcAft>
+                <a:spcPts val="400"/>
+              </a:spcAft>
+            </a:pPr>
+            <a:r>
+              <a:rPr sz="1150" b="1" i="0">
+                <a:solidFill>
+                  <a:srgbClr val="0F172A"/>
+                </a:solidFill>
+                <a:latin typeface="Calibri"/>
+              </a:rPr>
+              <a:t>✓  Confirmed vs needs-verification — </a:t>
+            </a:r>
+            <a:r>
+              <a:rPr sz="1050" b="0" i="0">
+                <a:solidFill>
+                  <a:srgbClr val="334155"/>
+                </a:solidFill>
+                <a:latin typeface="Calibri"/>
+              </a:rPr>
+              <a:t>The headline splits the £ you can trust from the £ to firm up.</a:t>
+            </a:r>
+          </a:p>
+        </p:txBody>
+      </p:sp>
+      <p:sp>
+        <p:nvSpPr>
+          <p:cNvPr id="24" name="Rounded Rectangle 23"/>
+          <p:cNvSpPr/>
+          <p:nvPr/>
+        </p:nvSpPr>
+        <p:spPr>
+          <a:xfrm>
+            <a:off x="411480" y="5468112"/>
+            <a:ext cx="11384280" cy="777240"/>
+          </a:xfrm>
+          <a:prstGeom prst="roundRect">
+            <a:avLst>
+              <a:gd name="adj" fmla="val 10000"/>
             </a:avLst>
           </a:prstGeom>
           <a:solidFill>
@@ -14411,14 +15415,14 @@
       </p:sp>
       <p:sp>
         <p:nvSpPr>
-          <p:cNvPr id="10" name="TextBox 9"/>
+          <p:cNvPr id="25" name="TextBox 24"/>
           <p:cNvSpPr txBox="1"/>
           <p:nvPr/>
         </p:nvSpPr>
         <p:spPr>
           <a:xfrm>
-            <a:off x="685800" y="2011680"/>
-            <a:ext cx="10881360" cy="914400"/>
+            <a:off x="685800" y="5596128"/>
+            <a:ext cx="10972800" cy="548640"/>
           </a:xfrm>
           <a:prstGeom prst="rect">
             <a:avLst/>
@@ -14433,899 +15437,29 @@
           <a:p>
             <a:pPr algn="l">
               <a:lnSpc>
-                <a:spcPct val="120000"/>
+                <a:spcPct val="115000"/>
               </a:lnSpc>
               <a:spcAft>
                 <a:spcPts val="400"/>
               </a:spcAft>
             </a:pPr>
             <a:r>
-              <a:rPr sz="1500" b="1" i="0">
+              <a:rPr sz="1250" b="1" i="0">
                 <a:solidFill>
                   <a:srgbClr val="2563EB"/>
                 </a:solidFill>
                 <a:latin typeface="Calibri"/>
               </a:rPr>
-              <a:t>The principle:  </a:t>
-            </a:r>
-            <a:r>
-              <a:rPr sz="1350" b="0" i="0">
+              <a:t>Result:  </a:t>
+            </a:r>
+            <a:r>
+              <a:rPr sz="1200" b="0" i="0">
                 <a:solidFill>
                   <a:srgbClr val="334155"/>
                 </a:solidFill>
                 <a:latin typeface="Calibri"/>
               </a:rPr>
-              <a:t>every learned or derived number stays auditable — a value a cost engineer can read and defend. No black-box weight ever touches the price. The AI narrates and explains; it never decides the number in secret.</a:t>
-            </a:r>
-          </a:p>
-        </p:txBody>
-      </p:sp>
-      <p:sp>
-        <p:nvSpPr>
-          <p:cNvPr id="11" name="Rounded Rectangle 10"/>
-          <p:cNvSpPr/>
-          <p:nvPr/>
-        </p:nvSpPr>
-        <p:spPr>
-          <a:xfrm>
-            <a:off x="411480" y="3200400"/>
-            <a:ext cx="11384280" cy="530352"/>
-          </a:xfrm>
-          <a:prstGeom prst="roundRect">
-            <a:avLst>
-              <a:gd name="adj" fmla="val 10000"/>
-            </a:avLst>
-          </a:prstGeom>
-          <a:solidFill>
-            <a:srgbClr val="F1F5F9"/>
-          </a:solidFill>
-          <a:ln>
-            <a:noFill/>
-          </a:ln>
-          <a:effectLst/>
-        </p:spPr>
-        <p:style>
-          <a:lnRef idx="1">
-            <a:schemeClr val="accent1"/>
-          </a:lnRef>
-          <a:fillRef idx="3">
-            <a:schemeClr val="accent1"/>
-          </a:fillRef>
-          <a:effectRef idx="2">
-            <a:schemeClr val="accent1"/>
-          </a:effectRef>
-          <a:fontRef idx="minor">
-            <a:schemeClr val="lt1"/>
-          </a:fontRef>
-        </p:style>
-        <p:txBody>
-          <a:bodyPr rtlCol="0" anchor="ctr"/>
-          <a:lstStyle/>
-          <a:p>
-            <a:pPr algn="ctr"/>
-          </a:p>
-        </p:txBody>
-      </p:sp>
-      <p:sp>
-        <p:nvSpPr>
-          <p:cNvPr id="12" name="Rectangle 11"/>
-          <p:cNvSpPr/>
-          <p:nvPr/>
-        </p:nvSpPr>
-        <p:spPr>
-          <a:xfrm>
-            <a:off x="411480" y="3200400"/>
-            <a:ext cx="82296" cy="530352"/>
-          </a:xfrm>
-          <a:prstGeom prst="rect">
-            <a:avLst/>
-          </a:prstGeom>
-          <a:solidFill>
-            <a:srgbClr val="059669"/>
-          </a:solidFill>
-          <a:ln>
-            <a:noFill/>
-          </a:ln>
-          <a:effectLst/>
-        </p:spPr>
-        <p:style>
-          <a:lnRef idx="1">
-            <a:schemeClr val="accent1"/>
-          </a:lnRef>
-          <a:fillRef idx="3">
-            <a:schemeClr val="accent1"/>
-          </a:fillRef>
-          <a:effectRef idx="2">
-            <a:schemeClr val="accent1"/>
-          </a:effectRef>
-          <a:fontRef idx="minor">
-            <a:schemeClr val="lt1"/>
-          </a:fontRef>
-        </p:style>
-        <p:txBody>
-          <a:bodyPr rtlCol="0" anchor="ctr"/>
-          <a:lstStyle/>
-          <a:p>
-            <a:pPr algn="ctr"/>
-          </a:p>
-        </p:txBody>
-      </p:sp>
-      <p:sp>
-        <p:nvSpPr>
-          <p:cNvPr id="13" name="TextBox 12"/>
-          <p:cNvSpPr txBox="1"/>
-          <p:nvPr/>
-        </p:nvSpPr>
-        <p:spPr>
-          <a:xfrm>
-            <a:off x="685800" y="3319272"/>
-            <a:ext cx="3291840" cy="320040"/>
-          </a:xfrm>
-          <a:prstGeom prst="rect">
-            <a:avLst/>
-          </a:prstGeom>
-          <a:noFill/>
-        </p:spPr>
-        <p:txBody>
-          <a:bodyPr wrap="square" anchor="t" lIns="0" rIns="0" tIns="0" bIns="0">
-            <a:spAutoFit/>
-          </a:bodyPr>
-          <a:lstStyle/>
-          <a:p>
-            <a:pPr algn="l">
-              <a:lnSpc>
-                <a:spcPct val="100000"/>
-              </a:lnSpc>
-              <a:spcAft>
-                <a:spcPts val="400"/>
-              </a:spcAft>
-            </a:pPr>
-            <a:r>
-              <a:rPr sz="1250" b="1" i="0">
-                <a:solidFill>
-                  <a:srgbClr val="059669"/>
-                </a:solidFill>
-                <a:latin typeface="Calibri"/>
-              </a:rPr>
-              <a:t>Continuous learning</a:t>
-            </a:r>
-          </a:p>
-        </p:txBody>
-      </p:sp>
-      <p:sp>
-        <p:nvSpPr>
-          <p:cNvPr id="14" name="TextBox 13"/>
-          <p:cNvSpPr txBox="1"/>
-          <p:nvPr/>
-        </p:nvSpPr>
-        <p:spPr>
-          <a:xfrm>
-            <a:off x="4114800" y="3319272"/>
-            <a:ext cx="7498079" cy="320040"/>
-          </a:xfrm>
-          <a:prstGeom prst="rect">
-            <a:avLst/>
-          </a:prstGeom>
-          <a:noFill/>
-        </p:spPr>
-        <p:txBody>
-          <a:bodyPr wrap="square" anchor="t" lIns="0" rIns="0" tIns="0" bIns="0">
-            <a:spAutoFit/>
-          </a:bodyPr>
-          <a:lstStyle/>
-          <a:p>
-            <a:pPr algn="l">
-              <a:lnSpc>
-                <a:spcPct val="100000"/>
-              </a:lnSpc>
-              <a:spcAft>
-                <a:spcPts val="400"/>
-              </a:spcAft>
-            </a:pPr>
-            <a:r>
-              <a:rPr sz="1200" b="0" i="0">
-                <a:solidFill>
-                  <a:srgbClr val="334155"/>
-                </a:solidFill>
-                <a:latin typeface="Calibri"/>
-              </a:rPr>
-              <a:t>Calibrates on YOUR quotes; conformal band with a guarantee</a:t>
-            </a:r>
-          </a:p>
-        </p:txBody>
-      </p:sp>
-      <p:sp>
-        <p:nvSpPr>
-          <p:cNvPr id="15" name="Rounded Rectangle 14"/>
-          <p:cNvSpPr/>
-          <p:nvPr/>
-        </p:nvSpPr>
-        <p:spPr>
-          <a:xfrm>
-            <a:off x="411480" y="3803904"/>
-            <a:ext cx="11384280" cy="530352"/>
-          </a:xfrm>
-          <a:prstGeom prst="roundRect">
-            <a:avLst>
-              <a:gd name="adj" fmla="val 10000"/>
-            </a:avLst>
-          </a:prstGeom>
-          <a:solidFill>
-            <a:srgbClr val="FFFFFF"/>
-          </a:solidFill>
-          <a:ln>
-            <a:noFill/>
-          </a:ln>
-          <a:effectLst/>
-        </p:spPr>
-        <p:style>
-          <a:lnRef idx="1">
-            <a:schemeClr val="accent1"/>
-          </a:lnRef>
-          <a:fillRef idx="3">
-            <a:schemeClr val="accent1"/>
-          </a:fillRef>
-          <a:effectRef idx="2">
-            <a:schemeClr val="accent1"/>
-          </a:effectRef>
-          <a:fontRef idx="minor">
-            <a:schemeClr val="lt1"/>
-          </a:fontRef>
-        </p:style>
-        <p:txBody>
-          <a:bodyPr rtlCol="0" anchor="ctr"/>
-          <a:lstStyle/>
-          <a:p>
-            <a:pPr algn="ctr"/>
-          </a:p>
-        </p:txBody>
-      </p:sp>
-      <p:sp>
-        <p:nvSpPr>
-          <p:cNvPr id="16" name="Rectangle 15"/>
-          <p:cNvSpPr/>
-          <p:nvPr/>
-        </p:nvSpPr>
-        <p:spPr>
-          <a:xfrm>
-            <a:off x="411480" y="3803904"/>
-            <a:ext cx="82296" cy="530352"/>
-          </a:xfrm>
-          <a:prstGeom prst="rect">
-            <a:avLst/>
-          </a:prstGeom>
-          <a:solidFill>
-            <a:srgbClr val="059669"/>
-          </a:solidFill>
-          <a:ln>
-            <a:noFill/>
-          </a:ln>
-          <a:effectLst/>
-        </p:spPr>
-        <p:style>
-          <a:lnRef idx="1">
-            <a:schemeClr val="accent1"/>
-          </a:lnRef>
-          <a:fillRef idx="3">
-            <a:schemeClr val="accent1"/>
-          </a:fillRef>
-          <a:effectRef idx="2">
-            <a:schemeClr val="accent1"/>
-          </a:effectRef>
-          <a:fontRef idx="minor">
-            <a:schemeClr val="lt1"/>
-          </a:fontRef>
-        </p:style>
-        <p:txBody>
-          <a:bodyPr rtlCol="0" anchor="ctr"/>
-          <a:lstStyle/>
-          <a:p>
-            <a:pPr algn="ctr"/>
-          </a:p>
-        </p:txBody>
-      </p:sp>
-      <p:sp>
-        <p:nvSpPr>
-          <p:cNvPr id="17" name="TextBox 16"/>
-          <p:cNvSpPr txBox="1"/>
-          <p:nvPr/>
-        </p:nvSpPr>
-        <p:spPr>
-          <a:xfrm>
-            <a:off x="685800" y="3922776"/>
-            <a:ext cx="3291840" cy="320040"/>
-          </a:xfrm>
-          <a:prstGeom prst="rect">
-            <a:avLst/>
-          </a:prstGeom>
-          <a:noFill/>
-        </p:spPr>
-        <p:txBody>
-          <a:bodyPr wrap="square" anchor="t" lIns="0" rIns="0" tIns="0" bIns="0">
-            <a:spAutoFit/>
-          </a:bodyPr>
-          <a:lstStyle/>
-          <a:p>
-            <a:pPr algn="l">
-              <a:lnSpc>
-                <a:spcPct val="100000"/>
-              </a:lnSpc>
-              <a:spcAft>
-                <a:spcPts val="400"/>
-              </a:spcAft>
-            </a:pPr>
-            <a:r>
-              <a:rPr sz="1250" b="1" i="0">
-                <a:solidFill>
-                  <a:srgbClr val="059669"/>
-                </a:solidFill>
-                <a:latin typeface="Calibri"/>
-              </a:rPr>
-              <a:t>Autonomous action</a:t>
-            </a:r>
-          </a:p>
-        </p:txBody>
-      </p:sp>
-      <p:sp>
-        <p:nvSpPr>
-          <p:cNvPr id="18" name="TextBox 17"/>
-          <p:cNvSpPr txBox="1"/>
-          <p:nvPr/>
-        </p:nvSpPr>
-        <p:spPr>
-          <a:xfrm>
-            <a:off x="4114800" y="3922776"/>
-            <a:ext cx="7498079" cy="320040"/>
-          </a:xfrm>
-          <a:prstGeom prst="rect">
-            <a:avLst/>
-          </a:prstGeom>
-          <a:noFill/>
-        </p:spPr>
-        <p:txBody>
-          <a:bodyPr wrap="square" anchor="t" lIns="0" rIns="0" tIns="0" bIns="0">
-            <a:spAutoFit/>
-          </a:bodyPr>
-          <a:lstStyle/>
-          <a:p>
-            <a:pPr algn="l">
-              <a:lnSpc>
-                <a:spcPct val="100000"/>
-              </a:lnSpc>
-              <a:spcAft>
-                <a:spcPts val="400"/>
-              </a:spcAft>
-            </a:pPr>
-            <a:r>
-              <a:rPr sz="1200" b="0" i="0">
-                <a:solidFill>
-                  <a:srgbClr val="334155"/>
-                </a:solidFill>
-                <a:latin typeface="Calibri"/>
-              </a:rPr>
-              <a:t>Agent opens findings unattended AND learns which convert</a:t>
-            </a:r>
-          </a:p>
-        </p:txBody>
-      </p:sp>
-      <p:sp>
-        <p:nvSpPr>
-          <p:cNvPr id="19" name="Rounded Rectangle 18"/>
-          <p:cNvSpPr/>
-          <p:nvPr/>
-        </p:nvSpPr>
-        <p:spPr>
-          <a:xfrm>
-            <a:off x="411480" y="4407408"/>
-            <a:ext cx="11384280" cy="530352"/>
-          </a:xfrm>
-          <a:prstGeom prst="roundRect">
-            <a:avLst>
-              <a:gd name="adj" fmla="val 10000"/>
-            </a:avLst>
-          </a:prstGeom>
-          <a:solidFill>
-            <a:srgbClr val="F1F5F9"/>
-          </a:solidFill>
-          <a:ln>
-            <a:noFill/>
-          </a:ln>
-          <a:effectLst/>
-        </p:spPr>
-        <p:style>
-          <a:lnRef idx="1">
-            <a:schemeClr val="accent1"/>
-          </a:lnRef>
-          <a:fillRef idx="3">
-            <a:schemeClr val="accent1"/>
-          </a:fillRef>
-          <a:effectRef idx="2">
-            <a:schemeClr val="accent1"/>
-          </a:effectRef>
-          <a:fontRef idx="minor">
-            <a:schemeClr val="lt1"/>
-          </a:fontRef>
-        </p:style>
-        <p:txBody>
-          <a:bodyPr rtlCol="0" anchor="ctr"/>
-          <a:lstStyle/>
-          <a:p>
-            <a:pPr algn="ctr"/>
-          </a:p>
-        </p:txBody>
-      </p:sp>
-      <p:sp>
-        <p:nvSpPr>
-          <p:cNvPr id="20" name="Rectangle 19"/>
-          <p:cNvSpPr/>
-          <p:nvPr/>
-        </p:nvSpPr>
-        <p:spPr>
-          <a:xfrm>
-            <a:off x="411480" y="4407408"/>
-            <a:ext cx="82296" cy="530352"/>
-          </a:xfrm>
-          <a:prstGeom prst="rect">
-            <a:avLst/>
-          </a:prstGeom>
-          <a:solidFill>
-            <a:srgbClr val="059669"/>
-          </a:solidFill>
-          <a:ln>
-            <a:noFill/>
-          </a:ln>
-          <a:effectLst/>
-        </p:spPr>
-        <p:style>
-          <a:lnRef idx="1">
-            <a:schemeClr val="accent1"/>
-          </a:lnRef>
-          <a:fillRef idx="3">
-            <a:schemeClr val="accent1"/>
-          </a:fillRef>
-          <a:effectRef idx="2">
-            <a:schemeClr val="accent1"/>
-          </a:effectRef>
-          <a:fontRef idx="minor">
-            <a:schemeClr val="lt1"/>
-          </a:fontRef>
-        </p:style>
-        <p:txBody>
-          <a:bodyPr rtlCol="0" anchor="ctr"/>
-          <a:lstStyle/>
-          <a:p>
-            <a:pPr algn="ctr"/>
-          </a:p>
-        </p:txBody>
-      </p:sp>
-      <p:sp>
-        <p:nvSpPr>
-          <p:cNvPr id="21" name="TextBox 20"/>
-          <p:cNvSpPr txBox="1"/>
-          <p:nvPr/>
-        </p:nvSpPr>
-        <p:spPr>
-          <a:xfrm>
-            <a:off x="685800" y="4526280"/>
-            <a:ext cx="3291840" cy="320040"/>
-          </a:xfrm>
-          <a:prstGeom prst="rect">
-            <a:avLst/>
-          </a:prstGeom>
-          <a:noFill/>
-        </p:spPr>
-        <p:txBody>
-          <a:bodyPr wrap="square" anchor="t" lIns="0" rIns="0" tIns="0" bIns="0">
-            <a:spAutoFit/>
-          </a:bodyPr>
-          <a:lstStyle/>
-          <a:p>
-            <a:pPr algn="l">
-              <a:lnSpc>
-                <a:spcPct val="100000"/>
-              </a:lnSpc>
-              <a:spcAft>
-                <a:spcPts val="400"/>
-              </a:spcAft>
-            </a:pPr>
-            <a:r>
-              <a:rPr sz="1250" b="1" i="0">
-                <a:solidFill>
-                  <a:srgbClr val="059669"/>
-                </a:solidFill>
-                <a:latin typeface="Calibri"/>
-              </a:rPr>
-              <a:t>Causal reasoning</a:t>
-            </a:r>
-          </a:p>
-        </p:txBody>
-      </p:sp>
-      <p:sp>
-        <p:nvSpPr>
-          <p:cNvPr id="22" name="TextBox 21"/>
-          <p:cNvSpPr txBox="1"/>
-          <p:nvPr/>
-        </p:nvSpPr>
-        <p:spPr>
-          <a:xfrm>
-            <a:off x="4114800" y="4526280"/>
-            <a:ext cx="7498079" cy="320040"/>
-          </a:xfrm>
-          <a:prstGeom prst="rect">
-            <a:avLst/>
-          </a:prstGeom>
-          <a:noFill/>
-        </p:spPr>
-        <p:txBody>
-          <a:bodyPr wrap="square" anchor="t" lIns="0" rIns="0" tIns="0" bIns="0">
-            <a:spAutoFit/>
-          </a:bodyPr>
-          <a:lstStyle/>
-          <a:p>
-            <a:pPr algn="l">
-              <a:lnSpc>
-                <a:spcPct val="100000"/>
-              </a:lnSpc>
-              <a:spcAft>
-                <a:spcPts val="400"/>
-              </a:spcAft>
-            </a:pPr>
-            <a:r>
-              <a:rPr sz="1200" b="0" i="0">
-                <a:solidFill>
-                  <a:srgbClr val="334155"/>
-                </a:solidFill>
-                <a:latin typeface="Calibri"/>
-              </a:rPr>
-              <a:t>Knows why a part costs what it does; coaches the negotiation</a:t>
-            </a:r>
-          </a:p>
-        </p:txBody>
-      </p:sp>
-      <p:sp>
-        <p:nvSpPr>
-          <p:cNvPr id="23" name="Rounded Rectangle 22"/>
-          <p:cNvSpPr/>
-          <p:nvPr/>
-        </p:nvSpPr>
-        <p:spPr>
-          <a:xfrm>
-            <a:off x="411480" y="5010912"/>
-            <a:ext cx="11384280" cy="530352"/>
-          </a:xfrm>
-          <a:prstGeom prst="roundRect">
-            <a:avLst>
-              <a:gd name="adj" fmla="val 10000"/>
-            </a:avLst>
-          </a:prstGeom>
-          <a:solidFill>
-            <a:srgbClr val="FFFFFF"/>
-          </a:solidFill>
-          <a:ln>
-            <a:noFill/>
-          </a:ln>
-          <a:effectLst/>
-        </p:spPr>
-        <p:style>
-          <a:lnRef idx="1">
-            <a:schemeClr val="accent1"/>
-          </a:lnRef>
-          <a:fillRef idx="3">
-            <a:schemeClr val="accent1"/>
-          </a:fillRef>
-          <a:effectRef idx="2">
-            <a:schemeClr val="accent1"/>
-          </a:effectRef>
-          <a:fontRef idx="minor">
-            <a:schemeClr val="lt1"/>
-          </a:fontRef>
-        </p:style>
-        <p:txBody>
-          <a:bodyPr rtlCol="0" anchor="ctr"/>
-          <a:lstStyle/>
-          <a:p>
-            <a:pPr algn="ctr"/>
-          </a:p>
-        </p:txBody>
-      </p:sp>
-      <p:sp>
-        <p:nvSpPr>
-          <p:cNvPr id="24" name="Rectangle 23"/>
-          <p:cNvSpPr/>
-          <p:nvPr/>
-        </p:nvSpPr>
-        <p:spPr>
-          <a:xfrm>
-            <a:off x="411480" y="5010912"/>
-            <a:ext cx="82296" cy="530352"/>
-          </a:xfrm>
-          <a:prstGeom prst="rect">
-            <a:avLst/>
-          </a:prstGeom>
-          <a:solidFill>
-            <a:srgbClr val="2563EB"/>
-          </a:solidFill>
-          <a:ln>
-            <a:noFill/>
-          </a:ln>
-          <a:effectLst/>
-        </p:spPr>
-        <p:style>
-          <a:lnRef idx="1">
-            <a:schemeClr val="accent1"/>
-          </a:lnRef>
-          <a:fillRef idx="3">
-            <a:schemeClr val="accent1"/>
-          </a:fillRef>
-          <a:effectRef idx="2">
-            <a:schemeClr val="accent1"/>
-          </a:effectRef>
-          <a:fontRef idx="minor">
-            <a:schemeClr val="lt1"/>
-          </a:fontRef>
-        </p:style>
-        <p:txBody>
-          <a:bodyPr rtlCol="0" anchor="ctr"/>
-          <a:lstStyle/>
-          <a:p>
-            <a:pPr algn="ctr"/>
-          </a:p>
-        </p:txBody>
-      </p:sp>
-      <p:sp>
-        <p:nvSpPr>
-          <p:cNvPr id="25" name="TextBox 24"/>
-          <p:cNvSpPr txBox="1"/>
-          <p:nvPr/>
-        </p:nvSpPr>
-        <p:spPr>
-          <a:xfrm>
-            <a:off x="685800" y="5129784"/>
-            <a:ext cx="3291840" cy="320040"/>
-          </a:xfrm>
-          <a:prstGeom prst="rect">
-            <a:avLst/>
-          </a:prstGeom>
-          <a:noFill/>
-        </p:spPr>
-        <p:txBody>
-          <a:bodyPr wrap="square" anchor="t" lIns="0" rIns="0" tIns="0" bIns="0">
-            <a:spAutoFit/>
-          </a:bodyPr>
-          <a:lstStyle/>
-          <a:p>
-            <a:pPr algn="l">
-              <a:lnSpc>
-                <a:spcPct val="100000"/>
-              </a:lnSpc>
-              <a:spcAft>
-                <a:spcPts val="400"/>
-              </a:spcAft>
-            </a:pPr>
-            <a:r>
-              <a:rPr sz="1250" b="1" i="0">
-                <a:solidFill>
-                  <a:srgbClr val="2563EB"/>
-                </a:solidFill>
-                <a:latin typeface="Calibri"/>
-              </a:rPr>
-              <a:t>Explainable — always</a:t>
-            </a:r>
-          </a:p>
-        </p:txBody>
-      </p:sp>
-      <p:sp>
-        <p:nvSpPr>
-          <p:cNvPr id="26" name="TextBox 25"/>
-          <p:cNvSpPr txBox="1"/>
-          <p:nvPr/>
-        </p:nvSpPr>
-        <p:spPr>
-          <a:xfrm>
-            <a:off x="4114800" y="5129784"/>
-            <a:ext cx="7498079" cy="320040"/>
-          </a:xfrm>
-          <a:prstGeom prst="rect">
-            <a:avLst/>
-          </a:prstGeom>
-          <a:noFill/>
-        </p:spPr>
-        <p:txBody>
-          <a:bodyPr wrap="square" anchor="t" lIns="0" rIns="0" tIns="0" bIns="0">
-            <a:spAutoFit/>
-          </a:bodyPr>
-          <a:lstStyle/>
-          <a:p>
-            <a:pPr algn="l">
-              <a:lnSpc>
-                <a:spcPct val="100000"/>
-              </a:lnSpc>
-              <a:spcAft>
-                <a:spcPts val="400"/>
-              </a:spcAft>
-            </a:pPr>
-            <a:r>
-              <a:rPr sz="1200" b="0" i="0">
-                <a:solidFill>
-                  <a:srgbClr val="334155"/>
-                </a:solidFill>
-                <a:latin typeface="Calibri"/>
-              </a:rPr>
-              <a:t>Every number defensible line-by-line; the competitor’s edge is the opposite</a:t>
-            </a:r>
-          </a:p>
-        </p:txBody>
-      </p:sp>
-      <p:sp>
-        <p:nvSpPr>
-          <p:cNvPr id="27" name="Rounded Rectangle 26"/>
-          <p:cNvSpPr/>
-          <p:nvPr/>
-        </p:nvSpPr>
-        <p:spPr>
-          <a:xfrm>
-            <a:off x="411480" y="5614416"/>
-            <a:ext cx="11384280" cy="530352"/>
-          </a:xfrm>
-          <a:prstGeom prst="roundRect">
-            <a:avLst>
-              <a:gd name="adj" fmla="val 10000"/>
-            </a:avLst>
-          </a:prstGeom>
-          <a:solidFill>
-            <a:srgbClr val="F1F5F9"/>
-          </a:solidFill>
-          <a:ln>
-            <a:noFill/>
-          </a:ln>
-          <a:effectLst/>
-        </p:spPr>
-        <p:style>
-          <a:lnRef idx="1">
-            <a:schemeClr val="accent1"/>
-          </a:lnRef>
-          <a:fillRef idx="3">
-            <a:schemeClr val="accent1"/>
-          </a:fillRef>
-          <a:effectRef idx="2">
-            <a:schemeClr val="accent1"/>
-          </a:effectRef>
-          <a:fontRef idx="minor">
-            <a:schemeClr val="lt1"/>
-          </a:fontRef>
-        </p:style>
-        <p:txBody>
-          <a:bodyPr rtlCol="0" anchor="ctr"/>
-          <a:lstStyle/>
-          <a:p>
-            <a:pPr algn="ctr"/>
-          </a:p>
-        </p:txBody>
-      </p:sp>
-      <p:sp>
-        <p:nvSpPr>
-          <p:cNvPr id="28" name="Rectangle 27"/>
-          <p:cNvSpPr/>
-          <p:nvPr/>
-        </p:nvSpPr>
-        <p:spPr>
-          <a:xfrm>
-            <a:off x="411480" y="5614416"/>
-            <a:ext cx="82296" cy="530352"/>
-          </a:xfrm>
-          <a:prstGeom prst="rect">
-            <a:avLst/>
-          </a:prstGeom>
-          <a:solidFill>
-            <a:srgbClr val="7C3AED"/>
-          </a:solidFill>
-          <a:ln>
-            <a:noFill/>
-          </a:ln>
-          <a:effectLst/>
-        </p:spPr>
-        <p:style>
-          <a:lnRef idx="1">
-            <a:schemeClr val="accent1"/>
-          </a:lnRef>
-          <a:fillRef idx="3">
-            <a:schemeClr val="accent1"/>
-          </a:fillRef>
-          <a:effectRef idx="2">
-            <a:schemeClr val="accent1"/>
-          </a:effectRef>
-          <a:fontRef idx="minor">
-            <a:schemeClr val="lt1"/>
-          </a:fontRef>
-        </p:style>
-        <p:txBody>
-          <a:bodyPr rtlCol="0" anchor="ctr"/>
-          <a:lstStyle/>
-          <a:p>
-            <a:pPr algn="ctr"/>
-          </a:p>
-        </p:txBody>
-      </p:sp>
-      <p:sp>
-        <p:nvSpPr>
-          <p:cNvPr id="29" name="TextBox 28"/>
-          <p:cNvSpPr txBox="1"/>
-          <p:nvPr/>
-        </p:nvSpPr>
-        <p:spPr>
-          <a:xfrm>
-            <a:off x="685800" y="5733288"/>
-            <a:ext cx="3291840" cy="320040"/>
-          </a:xfrm>
-          <a:prstGeom prst="rect">
-            <a:avLst/>
-          </a:prstGeom>
-          <a:noFill/>
-        </p:spPr>
-        <p:txBody>
-          <a:bodyPr wrap="square" anchor="t" lIns="0" rIns="0" tIns="0" bIns="0">
-            <a:spAutoFit/>
-          </a:bodyPr>
-          <a:lstStyle/>
-          <a:p>
-            <a:pPr algn="l">
-              <a:lnSpc>
-                <a:spcPct val="100000"/>
-              </a:lnSpc>
-              <a:spcAft>
-                <a:spcPts val="400"/>
-              </a:spcAft>
-            </a:pPr>
-            <a:r>
-              <a:rPr sz="1250" b="1" i="0">
-                <a:solidFill>
-                  <a:srgbClr val="7C3AED"/>
-                </a:solidFill>
-                <a:latin typeface="Calibri"/>
-              </a:rPr>
-              <a:t>Runs in your walls</a:t>
-            </a:r>
-          </a:p>
-        </p:txBody>
-      </p:sp>
-      <p:sp>
-        <p:nvSpPr>
-          <p:cNvPr id="30" name="TextBox 29"/>
-          <p:cNvSpPr txBox="1"/>
-          <p:nvPr/>
-        </p:nvSpPr>
-        <p:spPr>
-          <a:xfrm>
-            <a:off x="4114800" y="5733288"/>
-            <a:ext cx="7498079" cy="320040"/>
-          </a:xfrm>
-          <a:prstGeom prst="rect">
-            <a:avLst/>
-          </a:prstGeom>
-          <a:noFill/>
-        </p:spPr>
-        <p:txBody>
-          <a:bodyPr wrap="square" anchor="t" lIns="0" rIns="0" tIns="0" bIns="0">
-            <a:spAutoFit/>
-          </a:bodyPr>
-          <a:lstStyle/>
-          <a:p>
-            <a:pPr algn="l">
-              <a:lnSpc>
-                <a:spcPct val="100000"/>
-              </a:lnSpc>
-              <a:spcAft>
-                <a:spcPts val="400"/>
-              </a:spcAft>
-            </a:pPr>
-            <a:r>
-              <a:rPr sz="1200" b="0" i="0">
-                <a:solidFill>
-                  <a:srgbClr val="334155"/>
-                </a:solidFill>
-                <a:latin typeface="Calibri"/>
-              </a:rPr>
-              <a:t>On-premise; the knowledge is your IP and never leaves</a:t>
+              <a:t>the 2–3× over-costing is gone. That live ECU came back ASIL-B, 23 BOM lines, £69.11/board — with £37.65 confirmed and £24.64 honestly flagged to verify. Same photo, same answer, every run.</a:t>
             </a:r>
           </a:p>
         </p:txBody>
@@ -15612,7 +15746,7 @@
                 </a:solidFill>
                 <a:latin typeface="Calibri"/>
               </a:rPr>
-              <a:t>NEXT STEPS</a:t>
+              <a:t>THE DIFFERENTIATOR</a:t>
             </a:r>
           </a:p>
         </p:txBody>
@@ -15654,7 +15788,7 @@
                 </a:solidFill>
                 <a:latin typeface="Calibri"/>
               </a:rPr>
-              <a:t>Where we are, and the ask</a:t>
+              <a:t>Why ours is different — glass-box autonomy</a:t>
             </a:r>
           </a:p>
         </p:txBody>
@@ -15668,11 +15802,108 @@
         <p:spPr>
           <a:xfrm>
             <a:off x="411480" y="1828800"/>
-            <a:ext cx="5486400" cy="4023360"/>
+            <a:ext cx="11384280" cy="1188720"/>
           </a:xfrm>
           <a:prstGeom prst="roundRect">
             <a:avLst>
-              <a:gd name="adj" fmla="val 5000"/>
+              <a:gd name="adj" fmla="val 6000"/>
+            </a:avLst>
+          </a:prstGeom>
+          <a:solidFill>
+            <a:srgbClr val="EFF6FF"/>
+          </a:solidFill>
+          <a:ln>
+            <a:noFill/>
+          </a:ln>
+          <a:effectLst/>
+        </p:spPr>
+        <p:style>
+          <a:lnRef idx="1">
+            <a:schemeClr val="accent1"/>
+          </a:lnRef>
+          <a:fillRef idx="3">
+            <a:schemeClr val="accent1"/>
+          </a:fillRef>
+          <a:effectRef idx="2">
+            <a:schemeClr val="accent1"/>
+          </a:effectRef>
+          <a:fontRef idx="minor">
+            <a:schemeClr val="lt1"/>
+          </a:fontRef>
+        </p:style>
+        <p:txBody>
+          <a:bodyPr rtlCol="0" anchor="ctr"/>
+          <a:lstStyle/>
+          <a:p>
+            <a:pPr algn="ctr"/>
+          </a:p>
+        </p:txBody>
+      </p:sp>
+      <p:sp>
+        <p:nvSpPr>
+          <p:cNvPr id="10" name="TextBox 9"/>
+          <p:cNvSpPr txBox="1"/>
+          <p:nvPr/>
+        </p:nvSpPr>
+        <p:spPr>
+          <a:xfrm>
+            <a:off x="685800" y="2011680"/>
+            <a:ext cx="10881360" cy="914400"/>
+          </a:xfrm>
+          <a:prstGeom prst="rect">
+            <a:avLst/>
+          </a:prstGeom>
+          <a:noFill/>
+        </p:spPr>
+        <p:txBody>
+          <a:bodyPr wrap="square" anchor="t" lIns="0" rIns="0" tIns="0" bIns="0">
+            <a:spAutoFit/>
+          </a:bodyPr>
+          <a:lstStyle/>
+          <a:p>
+            <a:pPr algn="l">
+              <a:lnSpc>
+                <a:spcPct val="120000"/>
+              </a:lnSpc>
+              <a:spcAft>
+                <a:spcPts val="400"/>
+              </a:spcAft>
+            </a:pPr>
+            <a:r>
+              <a:rPr sz="1500" b="1" i="0">
+                <a:solidFill>
+                  <a:srgbClr val="2563EB"/>
+                </a:solidFill>
+                <a:latin typeface="Calibri"/>
+              </a:rPr>
+              <a:t>The principle:  </a:t>
+            </a:r>
+            <a:r>
+              <a:rPr sz="1350" b="0" i="0">
+                <a:solidFill>
+                  <a:srgbClr val="334155"/>
+                </a:solidFill>
+                <a:latin typeface="Calibri"/>
+              </a:rPr>
+              <a:t>every learned or derived number stays auditable — a value a cost engineer can read and defend. No black-box weight ever touches the price. The AI narrates and explains; it never decides the number in secret.</a:t>
+            </a:r>
+          </a:p>
+        </p:txBody>
+      </p:sp>
+      <p:sp>
+        <p:nvSpPr>
+          <p:cNvPr id="11" name="Rounded Rectangle 10"/>
+          <p:cNvSpPr/>
+          <p:nvPr/>
+        </p:nvSpPr>
+        <p:spPr>
+          <a:xfrm>
+            <a:off x="411480" y="3200400"/>
+            <a:ext cx="11384280" cy="530352"/>
+          </a:xfrm>
+          <a:prstGeom prst="roundRect">
+            <a:avLst>
+              <a:gd name="adj" fmla="val 10000"/>
             </a:avLst>
           </a:prstGeom>
           <a:solidFill>
@@ -15707,319 +15938,20 @@
       </p:sp>
       <p:sp>
         <p:nvSpPr>
-          <p:cNvPr id="10" name="TextBox 9"/>
-          <p:cNvSpPr txBox="1"/>
-          <p:nvPr/>
-        </p:nvSpPr>
-        <p:spPr>
-          <a:xfrm>
-            <a:off x="685800" y="2057400"/>
-            <a:ext cx="4937760" cy="365760"/>
-          </a:xfrm>
-          <a:prstGeom prst="rect">
-            <a:avLst/>
-          </a:prstGeom>
-          <a:noFill/>
-        </p:spPr>
-        <p:txBody>
-          <a:bodyPr wrap="square" anchor="t" lIns="0" rIns="0" tIns="0" bIns="0">
-            <a:spAutoFit/>
-          </a:bodyPr>
-          <a:lstStyle/>
-          <a:p>
-            <a:pPr algn="l">
-              <a:lnSpc>
-                <a:spcPct val="100000"/>
-              </a:lnSpc>
-              <a:spcAft>
-                <a:spcPts val="400"/>
-              </a:spcAft>
-            </a:pPr>
-            <a:r>
-              <a:rPr sz="1600" b="1" i="0">
-                <a:solidFill>
-                  <a:srgbClr val="059669"/>
-                </a:solidFill>
-                <a:latin typeface="Calibri"/>
-              </a:rPr>
-              <a:t>Status today</a:t>
-            </a:r>
-          </a:p>
-        </p:txBody>
-      </p:sp>
-      <p:sp>
-        <p:nvSpPr>
-          <p:cNvPr id="11" name="TextBox 10"/>
-          <p:cNvSpPr txBox="1"/>
-          <p:nvPr/>
-        </p:nvSpPr>
-        <p:spPr>
-          <a:xfrm>
-            <a:off x="685800" y="2560320"/>
-            <a:ext cx="4937760" cy="457200"/>
-          </a:xfrm>
-          <a:prstGeom prst="rect">
-            <a:avLst/>
-          </a:prstGeom>
-          <a:noFill/>
-        </p:spPr>
-        <p:txBody>
-          <a:bodyPr wrap="square" anchor="t" lIns="0" rIns="0" tIns="0" bIns="0">
-            <a:spAutoFit/>
-          </a:bodyPr>
-          <a:lstStyle/>
-          <a:p>
-            <a:pPr algn="l">
-              <a:lnSpc>
-                <a:spcPct val="100000"/>
-              </a:lnSpc>
-              <a:spcAft>
-                <a:spcPts val="400"/>
-              </a:spcAft>
-            </a:pPr>
-            <a:r>
-              <a:rPr sz="1300" b="1" i="0">
-                <a:solidFill>
-                  <a:srgbClr val="059669"/>
-                </a:solidFill>
-                <a:latin typeface="Calibri"/>
-              </a:rPr>
-              <a:t>✓  </a:t>
-            </a:r>
-            <a:r>
-              <a:rPr sz="1250" b="0" i="0">
-                <a:solidFill>
-                  <a:srgbClr val="334155"/>
-                </a:solidFill>
-                <a:latin typeface="Calibri"/>
-              </a:rPr>
-              <a:t>All capabilities built, tested (813 tests) and live — incl. 5 new for 2026</a:t>
-            </a:r>
-          </a:p>
-        </p:txBody>
-      </p:sp>
-      <p:sp>
-        <p:nvSpPr>
-          <p:cNvPr id="12" name="TextBox 11"/>
-          <p:cNvSpPr txBox="1"/>
-          <p:nvPr/>
-        </p:nvSpPr>
-        <p:spPr>
-          <a:xfrm>
-            <a:off x="685800" y="3063239"/>
-            <a:ext cx="4937760" cy="457200"/>
-          </a:xfrm>
-          <a:prstGeom prst="rect">
-            <a:avLst/>
-          </a:prstGeom>
-          <a:noFill/>
-        </p:spPr>
-        <p:txBody>
-          <a:bodyPr wrap="square" anchor="t" lIns="0" rIns="0" tIns="0" bIns="0">
-            <a:spAutoFit/>
-          </a:bodyPr>
-          <a:lstStyle/>
-          <a:p>
-            <a:pPr algn="l">
-              <a:lnSpc>
-                <a:spcPct val="100000"/>
-              </a:lnSpc>
-              <a:spcAft>
-                <a:spcPts val="400"/>
-              </a:spcAft>
-            </a:pPr>
-            <a:r>
-              <a:rPr sz="1300" b="1" i="0">
-                <a:solidFill>
-                  <a:srgbClr val="059669"/>
-                </a:solidFill>
-                <a:latin typeface="Calibri"/>
-              </a:rPr>
-              <a:t>✓  </a:t>
-            </a:r>
-            <a:r>
-              <a:rPr sz="1250" b="0" i="0">
-                <a:solidFill>
-                  <a:srgbClr val="334155"/>
-                </a:solidFill>
-                <a:latin typeface="Calibri"/>
-              </a:rPr>
-              <a:t>Verified end-to-end on the running system</a:t>
-            </a:r>
-          </a:p>
-        </p:txBody>
-      </p:sp>
-      <p:sp>
-        <p:nvSpPr>
-          <p:cNvPr id="13" name="TextBox 12"/>
-          <p:cNvSpPr txBox="1"/>
-          <p:nvPr/>
-        </p:nvSpPr>
-        <p:spPr>
-          <a:xfrm>
-            <a:off x="685800" y="3566160"/>
-            <a:ext cx="4937760" cy="457200"/>
-          </a:xfrm>
-          <a:prstGeom prst="rect">
-            <a:avLst/>
-          </a:prstGeom>
-          <a:noFill/>
-        </p:spPr>
-        <p:txBody>
-          <a:bodyPr wrap="square" anchor="t" lIns="0" rIns="0" tIns="0" bIns="0">
-            <a:spAutoFit/>
-          </a:bodyPr>
-          <a:lstStyle/>
-          <a:p>
-            <a:pPr algn="l">
-              <a:lnSpc>
-                <a:spcPct val="100000"/>
-              </a:lnSpc>
-              <a:spcAft>
-                <a:spcPts val="400"/>
-              </a:spcAft>
-            </a:pPr>
-            <a:r>
-              <a:rPr sz="1300" b="1" i="0">
-                <a:solidFill>
-                  <a:srgbClr val="059669"/>
-                </a:solidFill>
-                <a:latin typeface="Calibri"/>
-              </a:rPr>
-              <a:t>✓  </a:t>
-            </a:r>
-            <a:r>
-              <a:rPr sz="1250" b="0" i="0">
-                <a:solidFill>
-                  <a:srgbClr val="334155"/>
-                </a:solidFill>
-                <a:latin typeface="Calibri"/>
-              </a:rPr>
-              <a:t>Zero extra licence cost — built into our tool</a:t>
-            </a:r>
-          </a:p>
-        </p:txBody>
-      </p:sp>
-      <p:sp>
-        <p:nvSpPr>
-          <p:cNvPr id="14" name="TextBox 13"/>
-          <p:cNvSpPr txBox="1"/>
-          <p:nvPr/>
-        </p:nvSpPr>
-        <p:spPr>
-          <a:xfrm>
-            <a:off x="685800" y="4069080"/>
-            <a:ext cx="4937760" cy="457200"/>
-          </a:xfrm>
-          <a:prstGeom prst="rect">
-            <a:avLst/>
-          </a:prstGeom>
-          <a:noFill/>
-        </p:spPr>
-        <p:txBody>
-          <a:bodyPr wrap="square" anchor="t" lIns="0" rIns="0" tIns="0" bIns="0">
-            <a:spAutoFit/>
-          </a:bodyPr>
-          <a:lstStyle/>
-          <a:p>
-            <a:pPr algn="l">
-              <a:lnSpc>
-                <a:spcPct val="100000"/>
-              </a:lnSpc>
-              <a:spcAft>
-                <a:spcPts val="400"/>
-              </a:spcAft>
-            </a:pPr>
-            <a:r>
-              <a:rPr sz="1300" b="1" i="0">
-                <a:solidFill>
-                  <a:srgbClr val="059669"/>
-                </a:solidFill>
-                <a:latin typeface="Calibri"/>
-              </a:rPr>
-              <a:t>✓  </a:t>
-            </a:r>
-            <a:r>
-              <a:rPr sz="1250" b="0" i="0">
-                <a:solidFill>
-                  <a:srgbClr val="334155"/>
-                </a:solidFill>
-                <a:latin typeface="Calibri"/>
-              </a:rPr>
-              <a:t>Runs on-premise; no data leaves the company</a:t>
-            </a:r>
-          </a:p>
-        </p:txBody>
-      </p:sp>
-      <p:sp>
-        <p:nvSpPr>
-          <p:cNvPr id="15" name="TextBox 14"/>
-          <p:cNvSpPr txBox="1"/>
-          <p:nvPr/>
-        </p:nvSpPr>
-        <p:spPr>
-          <a:xfrm>
-            <a:off x="685800" y="4709160"/>
-            <a:ext cx="4937760" cy="1005840"/>
-          </a:xfrm>
-          <a:prstGeom prst="rect">
-            <a:avLst/>
-          </a:prstGeom>
-          <a:noFill/>
-        </p:spPr>
-        <p:txBody>
-          <a:bodyPr wrap="square" anchor="t" lIns="0" rIns="0" tIns="0" bIns="0">
-            <a:spAutoFit/>
-          </a:bodyPr>
-          <a:lstStyle/>
-          <a:p>
-            <a:pPr algn="l">
-              <a:lnSpc>
-                <a:spcPct val="115000"/>
-              </a:lnSpc>
-              <a:spcAft>
-                <a:spcPts val="400"/>
-              </a:spcAft>
-            </a:pPr>
-            <a:r>
-              <a:rPr sz="1200" b="1" i="0">
-                <a:solidFill>
-                  <a:srgbClr val="0F172A"/>
-                </a:solidFill>
-                <a:latin typeface="Calibri"/>
-              </a:rPr>
-              <a:t>Honest note: </a:t>
-            </a:r>
-            <a:r>
-              <a:rPr sz="1200" b="0" i="0">
-                <a:solidFill>
-                  <a:srgbClr val="334155"/>
-                </a:solidFill>
-                <a:latin typeface="Calibri"/>
-              </a:rPr>
-              <a:t>the intelligence starts empty and grows with use. The mechanism is proven; the value builds as we feed it.</a:t>
-            </a:r>
-          </a:p>
-        </p:txBody>
-      </p:sp>
-      <p:sp>
-        <p:nvSpPr>
-          <p:cNvPr id="16" name="Rounded Rectangle 15"/>
+          <p:cNvPr id="12" name="Rectangle 11"/>
           <p:cNvSpPr/>
           <p:nvPr/>
         </p:nvSpPr>
         <p:spPr>
           <a:xfrm>
-            <a:off x="6263640" y="1828800"/>
-            <a:ext cx="5532120" cy="4023360"/>
-          </a:xfrm>
-          <a:prstGeom prst="roundRect">
-            <a:avLst>
-              <a:gd name="adj" fmla="val 5000"/>
-            </a:avLst>
+            <a:off x="411480" y="3200400"/>
+            <a:ext cx="82296" cy="530352"/>
+          </a:xfrm>
+          <a:prstGeom prst="rect">
+            <a:avLst/>
           </a:prstGeom>
           <a:solidFill>
-            <a:srgbClr val="EFF6FF"/>
+            <a:srgbClr val="059669"/>
           </a:solidFill>
           <a:ln>
             <a:noFill/>
@@ -16050,14 +15982,14 @@
       </p:sp>
       <p:sp>
         <p:nvSpPr>
-          <p:cNvPr id="17" name="TextBox 16"/>
+          <p:cNvPr id="13" name="TextBox 12"/>
           <p:cNvSpPr txBox="1"/>
           <p:nvPr/>
         </p:nvSpPr>
         <p:spPr>
           <a:xfrm>
-            <a:off x="6537960" y="2057400"/>
-            <a:ext cx="4937760" cy="365760"/>
+            <a:off x="685800" y="3319272"/>
+            <a:ext cx="3291840" cy="320040"/>
           </a:xfrm>
           <a:prstGeom prst="rect">
             <a:avLst/>
@@ -16079,27 +16011,27 @@
               </a:spcAft>
             </a:pPr>
             <a:r>
-              <a:rPr sz="1600" b="1" i="0">
-                <a:solidFill>
-                  <a:srgbClr val="2563EB"/>
-                </a:solidFill>
-                <a:latin typeface="Calibri"/>
-              </a:rPr>
-              <a:t>The ask — three small decisions</a:t>
-            </a:r>
-          </a:p>
-        </p:txBody>
-      </p:sp>
-      <p:sp>
-        <p:nvSpPr>
-          <p:cNvPr id="18" name="TextBox 17"/>
+              <a:rPr sz="1250" b="1" i="0">
+                <a:solidFill>
+                  <a:srgbClr val="059669"/>
+                </a:solidFill>
+                <a:latin typeface="Calibri"/>
+              </a:rPr>
+              <a:t>Continuous learning</a:t>
+            </a:r>
+          </a:p>
+        </p:txBody>
+      </p:sp>
+      <p:sp>
+        <p:nvSpPr>
+          <p:cNvPr id="14" name="TextBox 13"/>
           <p:cNvSpPr txBox="1"/>
           <p:nvPr/>
         </p:nvSpPr>
         <p:spPr>
           <a:xfrm>
-            <a:off x="6537960" y="2606040"/>
-            <a:ext cx="5029200" cy="914400"/>
+            <a:off x="4114800" y="3319272"/>
+            <a:ext cx="7498079" cy="320040"/>
           </a:xfrm>
           <a:prstGeom prst="rect">
             <a:avLst/>
@@ -16114,181 +16046,42 @@
           <a:p>
             <a:pPr algn="l">
               <a:lnSpc>
-                <a:spcPct val="110000"/>
-              </a:lnSpc>
-              <a:spcAft>
-                <a:spcPts val="300"/>
-              </a:spcAft>
-            </a:pPr>
-            <a:r>
-              <a:rPr sz="1350" b="1" i="0">
-                <a:solidFill>
-                  <a:srgbClr val="0F172A"/>
-                </a:solidFill>
-                <a:latin typeface="Calibri"/>
-              </a:rPr>
-              <a:t>1.  Adopt the habit</a:t>
-            </a:r>
-          </a:p>
-          <a:p>
-            <a:pPr algn="l">
-              <a:lnSpc>
-                <a:spcPct val="110000"/>
-              </a:lnSpc>
-              <a:spcAft>
-                <a:spcPts val="300"/>
-              </a:spcAft>
-            </a:pPr>
-            <a:r>
-              <a:rPr sz="1150" b="0" i="0">
+                <a:spcPct val="100000"/>
+              </a:lnSpc>
+              <a:spcAft>
+                <a:spcPts val="400"/>
+              </a:spcAft>
+            </a:pPr>
+            <a:r>
+              <a:rPr sz="1200" b="0" i="0">
                 <a:solidFill>
                   <a:srgbClr val="334155"/>
                 </a:solidFill>
                 <a:latin typeface="Calibri"/>
               </a:rPr>
-              <a:t>     Make "Log Actual £" part of the quote-handling routine. One click per quote.</a:t>
-            </a:r>
-          </a:p>
-        </p:txBody>
-      </p:sp>
-      <p:sp>
-        <p:nvSpPr>
-          <p:cNvPr id="19" name="TextBox 18"/>
-          <p:cNvSpPr txBox="1"/>
-          <p:nvPr/>
-        </p:nvSpPr>
-        <p:spPr>
-          <a:xfrm>
-            <a:off x="6537960" y="3566160"/>
-            <a:ext cx="5029200" cy="914400"/>
-          </a:xfrm>
-          <a:prstGeom prst="rect">
-            <a:avLst/>
-          </a:prstGeom>
-          <a:noFill/>
-        </p:spPr>
-        <p:txBody>
-          <a:bodyPr wrap="square" anchor="t" lIns="0" rIns="0" tIns="0" bIns="0">
-            <a:spAutoFit/>
-          </a:bodyPr>
-          <a:lstStyle/>
-          <a:p>
-            <a:pPr algn="l">
-              <a:lnSpc>
-                <a:spcPct val="110000"/>
-              </a:lnSpc>
-              <a:spcAft>
-                <a:spcPts val="300"/>
-              </a:spcAft>
-            </a:pPr>
-            <a:r>
-              <a:rPr sz="1350" b="1" i="0">
-                <a:solidFill>
-                  <a:srgbClr val="0F172A"/>
-                </a:solidFill>
-                <a:latin typeface="Calibri"/>
-              </a:rPr>
-              <a:t>2.  Seed the memory</a:t>
-            </a:r>
-          </a:p>
-          <a:p>
-            <a:pPr algn="l">
-              <a:lnSpc>
-                <a:spcPct val="110000"/>
-              </a:lnSpc>
-              <a:spcAft>
-                <a:spcPts val="300"/>
-              </a:spcAft>
-            </a:pPr>
-            <a:r>
-              <a:rPr sz="1150" b="0" i="0">
-                <a:solidFill>
-                  <a:srgbClr val="334155"/>
-                </a:solidFill>
-                <a:latin typeface="Calibri"/>
-              </a:rPr>
-              <a:t>     Approve a one-off import of historical quotes so the tool starts smart (~1–2 days of effort).</a:t>
-            </a:r>
-          </a:p>
-        </p:txBody>
-      </p:sp>
-      <p:sp>
-        <p:nvSpPr>
-          <p:cNvPr id="20" name="TextBox 19"/>
-          <p:cNvSpPr txBox="1"/>
-          <p:nvPr/>
-        </p:nvSpPr>
-        <p:spPr>
-          <a:xfrm>
-            <a:off x="6537960" y="4526280"/>
-            <a:ext cx="5029200" cy="914400"/>
-          </a:xfrm>
-          <a:prstGeom prst="rect">
-            <a:avLst/>
-          </a:prstGeom>
-          <a:noFill/>
-        </p:spPr>
-        <p:txBody>
-          <a:bodyPr wrap="square" anchor="t" lIns="0" rIns="0" tIns="0" bIns="0">
-            <a:spAutoFit/>
-          </a:bodyPr>
-          <a:lstStyle/>
-          <a:p>
-            <a:pPr algn="l">
-              <a:lnSpc>
-                <a:spcPct val="110000"/>
-              </a:lnSpc>
-              <a:spcAft>
-                <a:spcPts val="300"/>
-              </a:spcAft>
-            </a:pPr>
-            <a:r>
-              <a:rPr sz="1350" b="1" i="0">
-                <a:solidFill>
-                  <a:srgbClr val="0F172A"/>
-                </a:solidFill>
-                <a:latin typeface="Calibri"/>
-              </a:rPr>
-              <a:t>3.  Review the findings</a:t>
-            </a:r>
-          </a:p>
-          <a:p>
-            <a:pPr algn="l">
-              <a:lnSpc>
-                <a:spcPct val="110000"/>
-              </a:lnSpc>
-              <a:spcAft>
-                <a:spcPts val="300"/>
-              </a:spcAft>
-            </a:pPr>
-            <a:r>
-              <a:rPr sz="1150" b="0" i="0">
-                <a:solidFill>
-                  <a:srgbClr val="334155"/>
-                </a:solidFill>
-                <a:latin typeface="Calibri"/>
-              </a:rPr>
-              <a:t>     Put the agent's monthly findings on the sourcing team's agenda — it is already finding money.</a:t>
-            </a:r>
-          </a:p>
-        </p:txBody>
-      </p:sp>
-      <p:sp>
-        <p:nvSpPr>
-          <p:cNvPr id="21" name="Rectangle 20"/>
+              <a:t>Calibrates on YOUR quotes; conformal band with a guarantee</a:t>
+            </a:r>
+          </a:p>
+        </p:txBody>
+      </p:sp>
+      <p:sp>
+        <p:nvSpPr>
+          <p:cNvPr id="15" name="Rounded Rectangle 14"/>
           <p:cNvSpPr/>
           <p:nvPr/>
         </p:nvSpPr>
         <p:spPr>
           <a:xfrm>
-            <a:off x="0" y="6711696"/>
-            <a:ext cx="12191695" cy="146304"/>
-          </a:xfrm>
-          <a:prstGeom prst="rect">
-            <a:avLst/>
+            <a:off x="411480" y="3803904"/>
+            <a:ext cx="11384280" cy="530352"/>
+          </a:xfrm>
+          <a:prstGeom prst="roundRect">
+            <a:avLst>
+              <a:gd name="adj" fmla="val 10000"/>
+            </a:avLst>
           </a:prstGeom>
           <a:solidFill>
-            <a:srgbClr val="4F46E5"/>
+            <a:srgbClr val="FFFFFF"/>
           </a:solidFill>
           <a:ln>
             <a:noFill/>
@@ -16314,6 +16107,656 @@
           <a:lstStyle/>
           <a:p>
             <a:pPr algn="ctr"/>
+          </a:p>
+        </p:txBody>
+      </p:sp>
+      <p:sp>
+        <p:nvSpPr>
+          <p:cNvPr id="16" name="Rectangle 15"/>
+          <p:cNvSpPr/>
+          <p:nvPr/>
+        </p:nvSpPr>
+        <p:spPr>
+          <a:xfrm>
+            <a:off x="411480" y="3803904"/>
+            <a:ext cx="82296" cy="530352"/>
+          </a:xfrm>
+          <a:prstGeom prst="rect">
+            <a:avLst/>
+          </a:prstGeom>
+          <a:solidFill>
+            <a:srgbClr val="059669"/>
+          </a:solidFill>
+          <a:ln>
+            <a:noFill/>
+          </a:ln>
+          <a:effectLst/>
+        </p:spPr>
+        <p:style>
+          <a:lnRef idx="1">
+            <a:schemeClr val="accent1"/>
+          </a:lnRef>
+          <a:fillRef idx="3">
+            <a:schemeClr val="accent1"/>
+          </a:fillRef>
+          <a:effectRef idx="2">
+            <a:schemeClr val="accent1"/>
+          </a:effectRef>
+          <a:fontRef idx="minor">
+            <a:schemeClr val="lt1"/>
+          </a:fontRef>
+        </p:style>
+        <p:txBody>
+          <a:bodyPr rtlCol="0" anchor="ctr"/>
+          <a:lstStyle/>
+          <a:p>
+            <a:pPr algn="ctr"/>
+          </a:p>
+        </p:txBody>
+      </p:sp>
+      <p:sp>
+        <p:nvSpPr>
+          <p:cNvPr id="17" name="TextBox 16"/>
+          <p:cNvSpPr txBox="1"/>
+          <p:nvPr/>
+        </p:nvSpPr>
+        <p:spPr>
+          <a:xfrm>
+            <a:off x="685800" y="3922776"/>
+            <a:ext cx="3291840" cy="320040"/>
+          </a:xfrm>
+          <a:prstGeom prst="rect">
+            <a:avLst/>
+          </a:prstGeom>
+          <a:noFill/>
+        </p:spPr>
+        <p:txBody>
+          <a:bodyPr wrap="square" anchor="t" lIns="0" rIns="0" tIns="0" bIns="0">
+            <a:spAutoFit/>
+          </a:bodyPr>
+          <a:lstStyle/>
+          <a:p>
+            <a:pPr algn="l">
+              <a:lnSpc>
+                <a:spcPct val="100000"/>
+              </a:lnSpc>
+              <a:spcAft>
+                <a:spcPts val="400"/>
+              </a:spcAft>
+            </a:pPr>
+            <a:r>
+              <a:rPr sz="1250" b="1" i="0">
+                <a:solidFill>
+                  <a:srgbClr val="059669"/>
+                </a:solidFill>
+                <a:latin typeface="Calibri"/>
+              </a:rPr>
+              <a:t>Autonomous action</a:t>
+            </a:r>
+          </a:p>
+        </p:txBody>
+      </p:sp>
+      <p:sp>
+        <p:nvSpPr>
+          <p:cNvPr id="18" name="TextBox 17"/>
+          <p:cNvSpPr txBox="1"/>
+          <p:nvPr/>
+        </p:nvSpPr>
+        <p:spPr>
+          <a:xfrm>
+            <a:off x="4114800" y="3922776"/>
+            <a:ext cx="7498079" cy="320040"/>
+          </a:xfrm>
+          <a:prstGeom prst="rect">
+            <a:avLst/>
+          </a:prstGeom>
+          <a:noFill/>
+        </p:spPr>
+        <p:txBody>
+          <a:bodyPr wrap="square" anchor="t" lIns="0" rIns="0" tIns="0" bIns="0">
+            <a:spAutoFit/>
+          </a:bodyPr>
+          <a:lstStyle/>
+          <a:p>
+            <a:pPr algn="l">
+              <a:lnSpc>
+                <a:spcPct val="100000"/>
+              </a:lnSpc>
+              <a:spcAft>
+                <a:spcPts val="400"/>
+              </a:spcAft>
+            </a:pPr>
+            <a:r>
+              <a:rPr sz="1200" b="0" i="0">
+                <a:solidFill>
+                  <a:srgbClr val="334155"/>
+                </a:solidFill>
+                <a:latin typeface="Calibri"/>
+              </a:rPr>
+              <a:t>Agent opens findings unattended AND learns which convert</a:t>
+            </a:r>
+          </a:p>
+        </p:txBody>
+      </p:sp>
+      <p:sp>
+        <p:nvSpPr>
+          <p:cNvPr id="19" name="Rounded Rectangle 18"/>
+          <p:cNvSpPr/>
+          <p:nvPr/>
+        </p:nvSpPr>
+        <p:spPr>
+          <a:xfrm>
+            <a:off x="411480" y="4407408"/>
+            <a:ext cx="11384280" cy="530352"/>
+          </a:xfrm>
+          <a:prstGeom prst="roundRect">
+            <a:avLst>
+              <a:gd name="adj" fmla="val 10000"/>
+            </a:avLst>
+          </a:prstGeom>
+          <a:solidFill>
+            <a:srgbClr val="F1F5F9"/>
+          </a:solidFill>
+          <a:ln>
+            <a:noFill/>
+          </a:ln>
+          <a:effectLst/>
+        </p:spPr>
+        <p:style>
+          <a:lnRef idx="1">
+            <a:schemeClr val="accent1"/>
+          </a:lnRef>
+          <a:fillRef idx="3">
+            <a:schemeClr val="accent1"/>
+          </a:fillRef>
+          <a:effectRef idx="2">
+            <a:schemeClr val="accent1"/>
+          </a:effectRef>
+          <a:fontRef idx="minor">
+            <a:schemeClr val="lt1"/>
+          </a:fontRef>
+        </p:style>
+        <p:txBody>
+          <a:bodyPr rtlCol="0" anchor="ctr"/>
+          <a:lstStyle/>
+          <a:p>
+            <a:pPr algn="ctr"/>
+          </a:p>
+        </p:txBody>
+      </p:sp>
+      <p:sp>
+        <p:nvSpPr>
+          <p:cNvPr id="20" name="Rectangle 19"/>
+          <p:cNvSpPr/>
+          <p:nvPr/>
+        </p:nvSpPr>
+        <p:spPr>
+          <a:xfrm>
+            <a:off x="411480" y="4407408"/>
+            <a:ext cx="82296" cy="530352"/>
+          </a:xfrm>
+          <a:prstGeom prst="rect">
+            <a:avLst/>
+          </a:prstGeom>
+          <a:solidFill>
+            <a:srgbClr val="059669"/>
+          </a:solidFill>
+          <a:ln>
+            <a:noFill/>
+          </a:ln>
+          <a:effectLst/>
+        </p:spPr>
+        <p:style>
+          <a:lnRef idx="1">
+            <a:schemeClr val="accent1"/>
+          </a:lnRef>
+          <a:fillRef idx="3">
+            <a:schemeClr val="accent1"/>
+          </a:fillRef>
+          <a:effectRef idx="2">
+            <a:schemeClr val="accent1"/>
+          </a:effectRef>
+          <a:fontRef idx="minor">
+            <a:schemeClr val="lt1"/>
+          </a:fontRef>
+        </p:style>
+        <p:txBody>
+          <a:bodyPr rtlCol="0" anchor="ctr"/>
+          <a:lstStyle/>
+          <a:p>
+            <a:pPr algn="ctr"/>
+          </a:p>
+        </p:txBody>
+      </p:sp>
+      <p:sp>
+        <p:nvSpPr>
+          <p:cNvPr id="21" name="TextBox 20"/>
+          <p:cNvSpPr txBox="1"/>
+          <p:nvPr/>
+        </p:nvSpPr>
+        <p:spPr>
+          <a:xfrm>
+            <a:off x="685800" y="4526280"/>
+            <a:ext cx="3291840" cy="320040"/>
+          </a:xfrm>
+          <a:prstGeom prst="rect">
+            <a:avLst/>
+          </a:prstGeom>
+          <a:noFill/>
+        </p:spPr>
+        <p:txBody>
+          <a:bodyPr wrap="square" anchor="t" lIns="0" rIns="0" tIns="0" bIns="0">
+            <a:spAutoFit/>
+          </a:bodyPr>
+          <a:lstStyle/>
+          <a:p>
+            <a:pPr algn="l">
+              <a:lnSpc>
+                <a:spcPct val="100000"/>
+              </a:lnSpc>
+              <a:spcAft>
+                <a:spcPts val="400"/>
+              </a:spcAft>
+            </a:pPr>
+            <a:r>
+              <a:rPr sz="1250" b="1" i="0">
+                <a:solidFill>
+                  <a:srgbClr val="059669"/>
+                </a:solidFill>
+                <a:latin typeface="Calibri"/>
+              </a:rPr>
+              <a:t>Causal reasoning</a:t>
+            </a:r>
+          </a:p>
+        </p:txBody>
+      </p:sp>
+      <p:sp>
+        <p:nvSpPr>
+          <p:cNvPr id="22" name="TextBox 21"/>
+          <p:cNvSpPr txBox="1"/>
+          <p:nvPr/>
+        </p:nvSpPr>
+        <p:spPr>
+          <a:xfrm>
+            <a:off x="4114800" y="4526280"/>
+            <a:ext cx="7498079" cy="320040"/>
+          </a:xfrm>
+          <a:prstGeom prst="rect">
+            <a:avLst/>
+          </a:prstGeom>
+          <a:noFill/>
+        </p:spPr>
+        <p:txBody>
+          <a:bodyPr wrap="square" anchor="t" lIns="0" rIns="0" tIns="0" bIns="0">
+            <a:spAutoFit/>
+          </a:bodyPr>
+          <a:lstStyle/>
+          <a:p>
+            <a:pPr algn="l">
+              <a:lnSpc>
+                <a:spcPct val="100000"/>
+              </a:lnSpc>
+              <a:spcAft>
+                <a:spcPts val="400"/>
+              </a:spcAft>
+            </a:pPr>
+            <a:r>
+              <a:rPr sz="1200" b="0" i="0">
+                <a:solidFill>
+                  <a:srgbClr val="334155"/>
+                </a:solidFill>
+                <a:latin typeface="Calibri"/>
+              </a:rPr>
+              <a:t>Knows why a part costs what it does; coaches the negotiation</a:t>
+            </a:r>
+          </a:p>
+        </p:txBody>
+      </p:sp>
+      <p:sp>
+        <p:nvSpPr>
+          <p:cNvPr id="23" name="Rounded Rectangle 22"/>
+          <p:cNvSpPr/>
+          <p:nvPr/>
+        </p:nvSpPr>
+        <p:spPr>
+          <a:xfrm>
+            <a:off x="411480" y="5010912"/>
+            <a:ext cx="11384280" cy="530352"/>
+          </a:xfrm>
+          <a:prstGeom prst="roundRect">
+            <a:avLst>
+              <a:gd name="adj" fmla="val 10000"/>
+            </a:avLst>
+          </a:prstGeom>
+          <a:solidFill>
+            <a:srgbClr val="FFFFFF"/>
+          </a:solidFill>
+          <a:ln>
+            <a:noFill/>
+          </a:ln>
+          <a:effectLst/>
+        </p:spPr>
+        <p:style>
+          <a:lnRef idx="1">
+            <a:schemeClr val="accent1"/>
+          </a:lnRef>
+          <a:fillRef idx="3">
+            <a:schemeClr val="accent1"/>
+          </a:fillRef>
+          <a:effectRef idx="2">
+            <a:schemeClr val="accent1"/>
+          </a:effectRef>
+          <a:fontRef idx="minor">
+            <a:schemeClr val="lt1"/>
+          </a:fontRef>
+        </p:style>
+        <p:txBody>
+          <a:bodyPr rtlCol="0" anchor="ctr"/>
+          <a:lstStyle/>
+          <a:p>
+            <a:pPr algn="ctr"/>
+          </a:p>
+        </p:txBody>
+      </p:sp>
+      <p:sp>
+        <p:nvSpPr>
+          <p:cNvPr id="24" name="Rectangle 23"/>
+          <p:cNvSpPr/>
+          <p:nvPr/>
+        </p:nvSpPr>
+        <p:spPr>
+          <a:xfrm>
+            <a:off x="411480" y="5010912"/>
+            <a:ext cx="82296" cy="530352"/>
+          </a:xfrm>
+          <a:prstGeom prst="rect">
+            <a:avLst/>
+          </a:prstGeom>
+          <a:solidFill>
+            <a:srgbClr val="2563EB"/>
+          </a:solidFill>
+          <a:ln>
+            <a:noFill/>
+          </a:ln>
+          <a:effectLst/>
+        </p:spPr>
+        <p:style>
+          <a:lnRef idx="1">
+            <a:schemeClr val="accent1"/>
+          </a:lnRef>
+          <a:fillRef idx="3">
+            <a:schemeClr val="accent1"/>
+          </a:fillRef>
+          <a:effectRef idx="2">
+            <a:schemeClr val="accent1"/>
+          </a:effectRef>
+          <a:fontRef idx="minor">
+            <a:schemeClr val="lt1"/>
+          </a:fontRef>
+        </p:style>
+        <p:txBody>
+          <a:bodyPr rtlCol="0" anchor="ctr"/>
+          <a:lstStyle/>
+          <a:p>
+            <a:pPr algn="ctr"/>
+          </a:p>
+        </p:txBody>
+      </p:sp>
+      <p:sp>
+        <p:nvSpPr>
+          <p:cNvPr id="25" name="TextBox 24"/>
+          <p:cNvSpPr txBox="1"/>
+          <p:nvPr/>
+        </p:nvSpPr>
+        <p:spPr>
+          <a:xfrm>
+            <a:off x="685800" y="5129784"/>
+            <a:ext cx="3291840" cy="320040"/>
+          </a:xfrm>
+          <a:prstGeom prst="rect">
+            <a:avLst/>
+          </a:prstGeom>
+          <a:noFill/>
+        </p:spPr>
+        <p:txBody>
+          <a:bodyPr wrap="square" anchor="t" lIns="0" rIns="0" tIns="0" bIns="0">
+            <a:spAutoFit/>
+          </a:bodyPr>
+          <a:lstStyle/>
+          <a:p>
+            <a:pPr algn="l">
+              <a:lnSpc>
+                <a:spcPct val="100000"/>
+              </a:lnSpc>
+              <a:spcAft>
+                <a:spcPts val="400"/>
+              </a:spcAft>
+            </a:pPr>
+            <a:r>
+              <a:rPr sz="1250" b="1" i="0">
+                <a:solidFill>
+                  <a:srgbClr val="2563EB"/>
+                </a:solidFill>
+                <a:latin typeface="Calibri"/>
+              </a:rPr>
+              <a:t>Explainable — always</a:t>
+            </a:r>
+          </a:p>
+        </p:txBody>
+      </p:sp>
+      <p:sp>
+        <p:nvSpPr>
+          <p:cNvPr id="26" name="TextBox 25"/>
+          <p:cNvSpPr txBox="1"/>
+          <p:nvPr/>
+        </p:nvSpPr>
+        <p:spPr>
+          <a:xfrm>
+            <a:off x="4114800" y="5129784"/>
+            <a:ext cx="7498079" cy="320040"/>
+          </a:xfrm>
+          <a:prstGeom prst="rect">
+            <a:avLst/>
+          </a:prstGeom>
+          <a:noFill/>
+        </p:spPr>
+        <p:txBody>
+          <a:bodyPr wrap="square" anchor="t" lIns="0" rIns="0" tIns="0" bIns="0">
+            <a:spAutoFit/>
+          </a:bodyPr>
+          <a:lstStyle/>
+          <a:p>
+            <a:pPr algn="l">
+              <a:lnSpc>
+                <a:spcPct val="100000"/>
+              </a:lnSpc>
+              <a:spcAft>
+                <a:spcPts val="400"/>
+              </a:spcAft>
+            </a:pPr>
+            <a:r>
+              <a:rPr sz="1200" b="0" i="0">
+                <a:solidFill>
+                  <a:srgbClr val="334155"/>
+                </a:solidFill>
+                <a:latin typeface="Calibri"/>
+              </a:rPr>
+              <a:t>Every number defensible line-by-line; the competitor’s edge is the opposite</a:t>
+            </a:r>
+          </a:p>
+        </p:txBody>
+      </p:sp>
+      <p:sp>
+        <p:nvSpPr>
+          <p:cNvPr id="27" name="Rounded Rectangle 26"/>
+          <p:cNvSpPr/>
+          <p:nvPr/>
+        </p:nvSpPr>
+        <p:spPr>
+          <a:xfrm>
+            <a:off x="411480" y="5614416"/>
+            <a:ext cx="11384280" cy="530352"/>
+          </a:xfrm>
+          <a:prstGeom prst="roundRect">
+            <a:avLst>
+              <a:gd name="adj" fmla="val 10000"/>
+            </a:avLst>
+          </a:prstGeom>
+          <a:solidFill>
+            <a:srgbClr val="F1F5F9"/>
+          </a:solidFill>
+          <a:ln>
+            <a:noFill/>
+          </a:ln>
+          <a:effectLst/>
+        </p:spPr>
+        <p:style>
+          <a:lnRef idx="1">
+            <a:schemeClr val="accent1"/>
+          </a:lnRef>
+          <a:fillRef idx="3">
+            <a:schemeClr val="accent1"/>
+          </a:fillRef>
+          <a:effectRef idx="2">
+            <a:schemeClr val="accent1"/>
+          </a:effectRef>
+          <a:fontRef idx="minor">
+            <a:schemeClr val="lt1"/>
+          </a:fontRef>
+        </p:style>
+        <p:txBody>
+          <a:bodyPr rtlCol="0" anchor="ctr"/>
+          <a:lstStyle/>
+          <a:p>
+            <a:pPr algn="ctr"/>
+          </a:p>
+        </p:txBody>
+      </p:sp>
+      <p:sp>
+        <p:nvSpPr>
+          <p:cNvPr id="28" name="Rectangle 27"/>
+          <p:cNvSpPr/>
+          <p:nvPr/>
+        </p:nvSpPr>
+        <p:spPr>
+          <a:xfrm>
+            <a:off x="411480" y="5614416"/>
+            <a:ext cx="82296" cy="530352"/>
+          </a:xfrm>
+          <a:prstGeom prst="rect">
+            <a:avLst/>
+          </a:prstGeom>
+          <a:solidFill>
+            <a:srgbClr val="7C3AED"/>
+          </a:solidFill>
+          <a:ln>
+            <a:noFill/>
+          </a:ln>
+          <a:effectLst/>
+        </p:spPr>
+        <p:style>
+          <a:lnRef idx="1">
+            <a:schemeClr val="accent1"/>
+          </a:lnRef>
+          <a:fillRef idx="3">
+            <a:schemeClr val="accent1"/>
+          </a:fillRef>
+          <a:effectRef idx="2">
+            <a:schemeClr val="accent1"/>
+          </a:effectRef>
+          <a:fontRef idx="minor">
+            <a:schemeClr val="lt1"/>
+          </a:fontRef>
+        </p:style>
+        <p:txBody>
+          <a:bodyPr rtlCol="0" anchor="ctr"/>
+          <a:lstStyle/>
+          <a:p>
+            <a:pPr algn="ctr"/>
+          </a:p>
+        </p:txBody>
+      </p:sp>
+      <p:sp>
+        <p:nvSpPr>
+          <p:cNvPr id="29" name="TextBox 28"/>
+          <p:cNvSpPr txBox="1"/>
+          <p:nvPr/>
+        </p:nvSpPr>
+        <p:spPr>
+          <a:xfrm>
+            <a:off x="685800" y="5733288"/>
+            <a:ext cx="3291840" cy="320040"/>
+          </a:xfrm>
+          <a:prstGeom prst="rect">
+            <a:avLst/>
+          </a:prstGeom>
+          <a:noFill/>
+        </p:spPr>
+        <p:txBody>
+          <a:bodyPr wrap="square" anchor="t" lIns="0" rIns="0" tIns="0" bIns="0">
+            <a:spAutoFit/>
+          </a:bodyPr>
+          <a:lstStyle/>
+          <a:p>
+            <a:pPr algn="l">
+              <a:lnSpc>
+                <a:spcPct val="100000"/>
+              </a:lnSpc>
+              <a:spcAft>
+                <a:spcPts val="400"/>
+              </a:spcAft>
+            </a:pPr>
+            <a:r>
+              <a:rPr sz="1250" b="1" i="0">
+                <a:solidFill>
+                  <a:srgbClr val="7C3AED"/>
+                </a:solidFill>
+                <a:latin typeface="Calibri"/>
+              </a:rPr>
+              <a:t>Runs in your walls</a:t>
+            </a:r>
+          </a:p>
+        </p:txBody>
+      </p:sp>
+      <p:sp>
+        <p:nvSpPr>
+          <p:cNvPr id="30" name="TextBox 29"/>
+          <p:cNvSpPr txBox="1"/>
+          <p:nvPr/>
+        </p:nvSpPr>
+        <p:spPr>
+          <a:xfrm>
+            <a:off x="4114800" y="5733288"/>
+            <a:ext cx="7498079" cy="320040"/>
+          </a:xfrm>
+          <a:prstGeom prst="rect">
+            <a:avLst/>
+          </a:prstGeom>
+          <a:noFill/>
+        </p:spPr>
+        <p:txBody>
+          <a:bodyPr wrap="square" anchor="t" lIns="0" rIns="0" tIns="0" bIns="0">
+            <a:spAutoFit/>
+          </a:bodyPr>
+          <a:lstStyle/>
+          <a:p>
+            <a:pPr algn="l">
+              <a:lnSpc>
+                <a:spcPct val="100000"/>
+              </a:lnSpc>
+              <a:spcAft>
+                <a:spcPts val="400"/>
+              </a:spcAft>
+            </a:pPr>
+            <a:r>
+              <a:rPr sz="1200" b="0" i="0">
+                <a:solidFill>
+                  <a:srgbClr val="334155"/>
+                </a:solidFill>
+                <a:latin typeface="Calibri"/>
+              </a:rPr>
+              <a:t>On-premise; the knowledge is your IP and never leaves</a:t>
+            </a:r>
           </a:p>
         </p:txBody>
       </p:sp>
@@ -17421,7 +17864,7 @@
                 </a:solidFill>
                 <a:latin typeface="Calibri"/>
               </a:rPr>
-              <a:t>813</a:t>
+              <a:t>917</a:t>
             </a:r>
           </a:p>
         </p:txBody>
@@ -17505,7 +17948,7 @@
                 </a:solidFill>
                 <a:latin typeface="Calibri"/>
               </a:rPr>
-              <a:t>Every capability is covered by automated tests and was exercised end-to-end on the running system.</a:t>
+              <a:t>Every capability is covered by automated tests (77 suites) and was exercised end-to-end on the running system.</a:t>
             </a:r>
           </a:p>
         </p:txBody>
@@ -17651,6 +18094,993 @@
               </a:rPr>
               <a:t>The knowledge stays in our database, on our servers — it becomes a company asset that gets more valuable with use, and it does not walk out of the door when an expert leaves.</a:t>
             </a:r>
+          </a:p>
+        </p:txBody>
+      </p:sp>
+    </p:spTree>
+  </p:cSld>
+  <p:clrMapOvr>
+    <a:masterClrMapping/>
+  </p:clrMapOvr>
+</p:sld>
+</file>
+
+<file path=ppt/slides/slide20.xml><?xml version="1.0" encoding="utf-8"?>
+<p:sld xmlns:a="http://schemas.openxmlformats.org/drawingml/2006/main" xmlns:p="http://schemas.openxmlformats.org/presentationml/2006/main" xmlns:r="http://schemas.openxmlformats.org/officeDocument/2006/relationships">
+  <p:cSld>
+    <p:spTree>
+      <p:nvGrpSpPr>
+        <p:cNvPr id="1" name=""/>
+        <p:cNvGrpSpPr/>
+        <p:nvPr/>
+      </p:nvGrpSpPr>
+      <p:grpSpPr/>
+      <p:sp>
+        <p:nvSpPr>
+          <p:cNvPr id="2" name="Rectangle 1"/>
+          <p:cNvSpPr/>
+          <p:nvPr/>
+        </p:nvSpPr>
+        <p:spPr>
+          <a:xfrm>
+            <a:off x="0" y="0"/>
+            <a:ext cx="12191695" cy="6858000"/>
+          </a:xfrm>
+          <a:prstGeom prst="rect">
+            <a:avLst/>
+          </a:prstGeom>
+          <a:solidFill>
+            <a:srgbClr val="FFFFFF"/>
+          </a:solidFill>
+          <a:ln>
+            <a:noFill/>
+          </a:ln>
+          <a:effectLst/>
+        </p:spPr>
+        <p:style>
+          <a:lnRef idx="1">
+            <a:schemeClr val="accent1"/>
+          </a:lnRef>
+          <a:fillRef idx="3">
+            <a:schemeClr val="accent1"/>
+          </a:fillRef>
+          <a:effectRef idx="2">
+            <a:schemeClr val="accent1"/>
+          </a:effectRef>
+          <a:fontRef idx="minor">
+            <a:schemeClr val="lt1"/>
+          </a:fontRef>
+        </p:style>
+        <p:txBody>
+          <a:bodyPr rtlCol="0" anchor="ctr"/>
+          <a:lstStyle/>
+          <a:p>
+            <a:pPr algn="ctr"/>
+          </a:p>
+        </p:txBody>
+      </p:sp>
+      <p:sp>
+        <p:nvSpPr>
+          <p:cNvPr id="3" name="Rounded Rectangle 2"/>
+          <p:cNvSpPr/>
+          <p:nvPr/>
+        </p:nvSpPr>
+        <p:spPr>
+          <a:xfrm>
+            <a:off x="320040" y="201168"/>
+            <a:ext cx="384048" cy="384048"/>
+          </a:xfrm>
+          <a:prstGeom prst="roundRect">
+            <a:avLst>
+              <a:gd name="adj" fmla="val 28000"/>
+            </a:avLst>
+          </a:prstGeom>
+          <a:solidFill>
+            <a:srgbClr val="4F46E5"/>
+          </a:solidFill>
+          <a:ln>
+            <a:noFill/>
+          </a:ln>
+          <a:effectLst/>
+        </p:spPr>
+        <p:style>
+          <a:lnRef idx="1">
+            <a:schemeClr val="accent1"/>
+          </a:lnRef>
+          <a:fillRef idx="3">
+            <a:schemeClr val="accent1"/>
+          </a:fillRef>
+          <a:effectRef idx="2">
+            <a:schemeClr val="accent1"/>
+          </a:effectRef>
+          <a:fontRef idx="minor">
+            <a:schemeClr val="lt1"/>
+          </a:fontRef>
+        </p:style>
+        <p:txBody>
+          <a:bodyPr rtlCol="0" anchor="ctr" lIns="0" rIns="0" tIns="0" bIns="0"/>
+          <a:lstStyle/>
+          <a:p>
+            <a:pPr algn="ctr"/>
+            <a:r>
+              <a:rPr sz="1700" b="1">
+                <a:solidFill>
+                  <a:srgbClr val="FFFFFF"/>
+                </a:solidFill>
+                <a:latin typeface="Calibri"/>
+              </a:rPr>
+              <a:t>cv</a:t>
+            </a:r>
+          </a:p>
+        </p:txBody>
+      </p:sp>
+      <p:sp>
+        <p:nvSpPr>
+          <p:cNvPr id="4" name="TextBox 3"/>
+          <p:cNvSpPr txBox="1"/>
+          <p:nvPr/>
+        </p:nvSpPr>
+        <p:spPr>
+          <a:xfrm>
+            <a:off x="795528" y="173736"/>
+            <a:ext cx="2377440" cy="292608"/>
+          </a:xfrm>
+          <a:prstGeom prst="rect">
+            <a:avLst/>
+          </a:prstGeom>
+          <a:noFill/>
+        </p:spPr>
+        <p:txBody>
+          <a:bodyPr wrap="square" anchor="t" lIns="0" rIns="0" tIns="0" bIns="0">
+            <a:spAutoFit/>
+          </a:bodyPr>
+          <a:lstStyle/>
+          <a:p>
+            <a:pPr algn="l">
+              <a:lnSpc>
+                <a:spcPct val="100000"/>
+              </a:lnSpc>
+              <a:spcAft>
+                <a:spcPts val="400"/>
+              </a:spcAft>
+            </a:pPr>
+            <a:r>
+              <a:rPr sz="1800" b="1" i="0">
+                <a:solidFill>
+                  <a:srgbClr val="2563EB"/>
+                </a:solidFill>
+                <a:latin typeface="Calibri"/>
+              </a:rPr>
+              <a:t>CostVision</a:t>
+            </a:r>
+          </a:p>
+        </p:txBody>
+      </p:sp>
+      <p:sp>
+        <p:nvSpPr>
+          <p:cNvPr id="5" name="TextBox 4"/>
+          <p:cNvSpPr txBox="1"/>
+          <p:nvPr/>
+        </p:nvSpPr>
+        <p:spPr>
+          <a:xfrm>
+            <a:off x="795528" y="420624"/>
+            <a:ext cx="2560320" cy="201168"/>
+          </a:xfrm>
+          <a:prstGeom prst="rect">
+            <a:avLst/>
+          </a:prstGeom>
+          <a:noFill/>
+        </p:spPr>
+        <p:txBody>
+          <a:bodyPr wrap="square" anchor="t" lIns="0" rIns="0" tIns="0" bIns="0">
+            <a:spAutoFit/>
+          </a:bodyPr>
+          <a:lstStyle/>
+          <a:p>
+            <a:pPr algn="l">
+              <a:lnSpc>
+                <a:spcPct val="100000"/>
+              </a:lnSpc>
+              <a:spcAft>
+                <a:spcPts val="400"/>
+              </a:spcAft>
+            </a:pPr>
+            <a:r>
+              <a:rPr sz="750" b="0" i="0">
+                <a:solidFill>
+                  <a:srgbClr val="64748B"/>
+                </a:solidFill>
+                <a:latin typeface="Calibri"/>
+              </a:rPr>
+              <a:t>AI  COST  INTELLIGENCE</a:t>
+            </a:r>
+          </a:p>
+        </p:txBody>
+      </p:sp>
+      <p:sp>
+        <p:nvSpPr>
+          <p:cNvPr id="6" name="Rectangle 5"/>
+          <p:cNvSpPr/>
+          <p:nvPr/>
+        </p:nvSpPr>
+        <p:spPr>
+          <a:xfrm>
+            <a:off x="0" y="713232"/>
+            <a:ext cx="12191695" cy="27940"/>
+          </a:xfrm>
+          <a:prstGeom prst="rect">
+            <a:avLst/>
+          </a:prstGeom>
+          <a:solidFill>
+            <a:srgbClr val="4F46E5"/>
+          </a:solidFill>
+          <a:ln>
+            <a:noFill/>
+          </a:ln>
+          <a:effectLst/>
+        </p:spPr>
+        <p:style>
+          <a:lnRef idx="1">
+            <a:schemeClr val="accent1"/>
+          </a:lnRef>
+          <a:fillRef idx="3">
+            <a:schemeClr val="accent1"/>
+          </a:fillRef>
+          <a:effectRef idx="2">
+            <a:schemeClr val="accent1"/>
+          </a:effectRef>
+          <a:fontRef idx="minor">
+            <a:schemeClr val="lt1"/>
+          </a:fontRef>
+        </p:style>
+        <p:txBody>
+          <a:bodyPr rtlCol="0" anchor="ctr"/>
+          <a:lstStyle/>
+          <a:p>
+            <a:pPr algn="ctr"/>
+          </a:p>
+        </p:txBody>
+      </p:sp>
+      <p:sp>
+        <p:nvSpPr>
+          <p:cNvPr id="7" name="TextBox 6"/>
+          <p:cNvSpPr txBox="1"/>
+          <p:nvPr/>
+        </p:nvSpPr>
+        <p:spPr>
+          <a:xfrm>
+            <a:off x="411480" y="868680"/>
+            <a:ext cx="10515600" cy="274320"/>
+          </a:xfrm>
+          <a:prstGeom prst="rect">
+            <a:avLst/>
+          </a:prstGeom>
+          <a:noFill/>
+        </p:spPr>
+        <p:txBody>
+          <a:bodyPr wrap="square" anchor="t" lIns="0" rIns="0" tIns="0" bIns="0">
+            <a:spAutoFit/>
+          </a:bodyPr>
+          <a:lstStyle/>
+          <a:p>
+            <a:pPr algn="l">
+              <a:lnSpc>
+                <a:spcPct val="100000"/>
+              </a:lnSpc>
+              <a:spcAft>
+                <a:spcPts val="400"/>
+              </a:spcAft>
+            </a:pPr>
+            <a:r>
+              <a:rPr sz="1100" b="1" i="0">
+                <a:solidFill>
+                  <a:srgbClr val="2563EB"/>
+                </a:solidFill>
+                <a:latin typeface="Calibri"/>
+              </a:rPr>
+              <a:t>NEXT STEPS</a:t>
+            </a:r>
+          </a:p>
+        </p:txBody>
+      </p:sp>
+      <p:sp>
+        <p:nvSpPr>
+          <p:cNvPr id="8" name="TextBox 7"/>
+          <p:cNvSpPr txBox="1"/>
+          <p:nvPr/>
+        </p:nvSpPr>
+        <p:spPr>
+          <a:xfrm>
+            <a:off x="411480" y="1115568"/>
+            <a:ext cx="11338560" cy="548640"/>
+          </a:xfrm>
+          <a:prstGeom prst="rect">
+            <a:avLst/>
+          </a:prstGeom>
+          <a:noFill/>
+        </p:spPr>
+        <p:txBody>
+          <a:bodyPr wrap="square" anchor="t" lIns="0" rIns="0" tIns="0" bIns="0">
+            <a:spAutoFit/>
+          </a:bodyPr>
+          <a:lstStyle/>
+          <a:p>
+            <a:pPr algn="l">
+              <a:lnSpc>
+                <a:spcPct val="100000"/>
+              </a:lnSpc>
+              <a:spcAft>
+                <a:spcPts val="400"/>
+              </a:spcAft>
+            </a:pPr>
+            <a:r>
+              <a:rPr sz="2700" b="1" i="0">
+                <a:solidFill>
+                  <a:srgbClr val="0F172A"/>
+                </a:solidFill>
+                <a:latin typeface="Calibri"/>
+              </a:rPr>
+              <a:t>Where we are, and the ask</a:t>
+            </a:r>
+          </a:p>
+        </p:txBody>
+      </p:sp>
+      <p:sp>
+        <p:nvSpPr>
+          <p:cNvPr id="9" name="Rounded Rectangle 8"/>
+          <p:cNvSpPr/>
+          <p:nvPr/>
+        </p:nvSpPr>
+        <p:spPr>
+          <a:xfrm>
+            <a:off x="411480" y="1828800"/>
+            <a:ext cx="5486400" cy="4023360"/>
+          </a:xfrm>
+          <a:prstGeom prst="roundRect">
+            <a:avLst>
+              <a:gd name="adj" fmla="val 5000"/>
+            </a:avLst>
+          </a:prstGeom>
+          <a:solidFill>
+            <a:srgbClr val="F1F5F9"/>
+          </a:solidFill>
+          <a:ln>
+            <a:noFill/>
+          </a:ln>
+          <a:effectLst/>
+        </p:spPr>
+        <p:style>
+          <a:lnRef idx="1">
+            <a:schemeClr val="accent1"/>
+          </a:lnRef>
+          <a:fillRef idx="3">
+            <a:schemeClr val="accent1"/>
+          </a:fillRef>
+          <a:effectRef idx="2">
+            <a:schemeClr val="accent1"/>
+          </a:effectRef>
+          <a:fontRef idx="minor">
+            <a:schemeClr val="lt1"/>
+          </a:fontRef>
+        </p:style>
+        <p:txBody>
+          <a:bodyPr rtlCol="0" anchor="ctr"/>
+          <a:lstStyle/>
+          <a:p>
+            <a:pPr algn="ctr"/>
+          </a:p>
+        </p:txBody>
+      </p:sp>
+      <p:sp>
+        <p:nvSpPr>
+          <p:cNvPr id="10" name="TextBox 9"/>
+          <p:cNvSpPr txBox="1"/>
+          <p:nvPr/>
+        </p:nvSpPr>
+        <p:spPr>
+          <a:xfrm>
+            <a:off x="685800" y="2057400"/>
+            <a:ext cx="4937760" cy="365760"/>
+          </a:xfrm>
+          <a:prstGeom prst="rect">
+            <a:avLst/>
+          </a:prstGeom>
+          <a:noFill/>
+        </p:spPr>
+        <p:txBody>
+          <a:bodyPr wrap="square" anchor="t" lIns="0" rIns="0" tIns="0" bIns="0">
+            <a:spAutoFit/>
+          </a:bodyPr>
+          <a:lstStyle/>
+          <a:p>
+            <a:pPr algn="l">
+              <a:lnSpc>
+                <a:spcPct val="100000"/>
+              </a:lnSpc>
+              <a:spcAft>
+                <a:spcPts val="400"/>
+              </a:spcAft>
+            </a:pPr>
+            <a:r>
+              <a:rPr sz="1600" b="1" i="0">
+                <a:solidFill>
+                  <a:srgbClr val="059669"/>
+                </a:solidFill>
+                <a:latin typeface="Calibri"/>
+              </a:rPr>
+              <a:t>Status today</a:t>
+            </a:r>
+          </a:p>
+        </p:txBody>
+      </p:sp>
+      <p:sp>
+        <p:nvSpPr>
+          <p:cNvPr id="11" name="TextBox 10"/>
+          <p:cNvSpPr txBox="1"/>
+          <p:nvPr/>
+        </p:nvSpPr>
+        <p:spPr>
+          <a:xfrm>
+            <a:off x="685800" y="2560320"/>
+            <a:ext cx="4937760" cy="457200"/>
+          </a:xfrm>
+          <a:prstGeom prst="rect">
+            <a:avLst/>
+          </a:prstGeom>
+          <a:noFill/>
+        </p:spPr>
+        <p:txBody>
+          <a:bodyPr wrap="square" anchor="t" lIns="0" rIns="0" tIns="0" bIns="0">
+            <a:spAutoFit/>
+          </a:bodyPr>
+          <a:lstStyle/>
+          <a:p>
+            <a:pPr algn="l">
+              <a:lnSpc>
+                <a:spcPct val="100000"/>
+              </a:lnSpc>
+              <a:spcAft>
+                <a:spcPts val="400"/>
+              </a:spcAft>
+            </a:pPr>
+            <a:r>
+              <a:rPr sz="1300" b="1" i="0">
+                <a:solidFill>
+                  <a:srgbClr val="059669"/>
+                </a:solidFill>
+                <a:latin typeface="Calibri"/>
+              </a:rPr>
+              <a:t>✓  </a:t>
+            </a:r>
+            <a:r>
+              <a:rPr sz="1250" b="0" i="0">
+                <a:solidFill>
+                  <a:srgbClr val="334155"/>
+                </a:solidFill>
+                <a:latin typeface="Calibri"/>
+              </a:rPr>
+              <a:t>All capabilities built, tested (917 tests) and live — incl. 6 new for 2026</a:t>
+            </a:r>
+          </a:p>
+        </p:txBody>
+      </p:sp>
+      <p:sp>
+        <p:nvSpPr>
+          <p:cNvPr id="12" name="TextBox 11"/>
+          <p:cNvSpPr txBox="1"/>
+          <p:nvPr/>
+        </p:nvSpPr>
+        <p:spPr>
+          <a:xfrm>
+            <a:off x="685800" y="3063239"/>
+            <a:ext cx="4937760" cy="457200"/>
+          </a:xfrm>
+          <a:prstGeom prst="rect">
+            <a:avLst/>
+          </a:prstGeom>
+          <a:noFill/>
+        </p:spPr>
+        <p:txBody>
+          <a:bodyPr wrap="square" anchor="t" lIns="0" rIns="0" tIns="0" bIns="0">
+            <a:spAutoFit/>
+          </a:bodyPr>
+          <a:lstStyle/>
+          <a:p>
+            <a:pPr algn="l">
+              <a:lnSpc>
+                <a:spcPct val="100000"/>
+              </a:lnSpc>
+              <a:spcAft>
+                <a:spcPts val="400"/>
+              </a:spcAft>
+            </a:pPr>
+            <a:r>
+              <a:rPr sz="1300" b="1" i="0">
+                <a:solidFill>
+                  <a:srgbClr val="059669"/>
+                </a:solidFill>
+                <a:latin typeface="Calibri"/>
+              </a:rPr>
+              <a:t>✓  </a:t>
+            </a:r>
+            <a:r>
+              <a:rPr sz="1250" b="0" i="0">
+                <a:solidFill>
+                  <a:srgbClr val="334155"/>
+                </a:solidFill>
+                <a:latin typeface="Calibri"/>
+              </a:rPr>
+              <a:t>Verified end-to-end on the running system</a:t>
+            </a:r>
+          </a:p>
+        </p:txBody>
+      </p:sp>
+      <p:sp>
+        <p:nvSpPr>
+          <p:cNvPr id="13" name="TextBox 12"/>
+          <p:cNvSpPr txBox="1"/>
+          <p:nvPr/>
+        </p:nvSpPr>
+        <p:spPr>
+          <a:xfrm>
+            <a:off x="685800" y="3566160"/>
+            <a:ext cx="4937760" cy="457200"/>
+          </a:xfrm>
+          <a:prstGeom prst="rect">
+            <a:avLst/>
+          </a:prstGeom>
+          <a:noFill/>
+        </p:spPr>
+        <p:txBody>
+          <a:bodyPr wrap="square" anchor="t" lIns="0" rIns="0" tIns="0" bIns="0">
+            <a:spAutoFit/>
+          </a:bodyPr>
+          <a:lstStyle/>
+          <a:p>
+            <a:pPr algn="l">
+              <a:lnSpc>
+                <a:spcPct val="100000"/>
+              </a:lnSpc>
+              <a:spcAft>
+                <a:spcPts val="400"/>
+              </a:spcAft>
+            </a:pPr>
+            <a:r>
+              <a:rPr sz="1300" b="1" i="0">
+                <a:solidFill>
+                  <a:srgbClr val="059669"/>
+                </a:solidFill>
+                <a:latin typeface="Calibri"/>
+              </a:rPr>
+              <a:t>✓  </a:t>
+            </a:r>
+            <a:r>
+              <a:rPr sz="1250" b="0" i="0">
+                <a:solidFill>
+                  <a:srgbClr val="334155"/>
+                </a:solidFill>
+                <a:latin typeface="Calibri"/>
+              </a:rPr>
+              <a:t>Zero extra licence cost — built into our tool</a:t>
+            </a:r>
+          </a:p>
+        </p:txBody>
+      </p:sp>
+      <p:sp>
+        <p:nvSpPr>
+          <p:cNvPr id="14" name="TextBox 13"/>
+          <p:cNvSpPr txBox="1"/>
+          <p:nvPr/>
+        </p:nvSpPr>
+        <p:spPr>
+          <a:xfrm>
+            <a:off x="685800" y="4069080"/>
+            <a:ext cx="4937760" cy="457200"/>
+          </a:xfrm>
+          <a:prstGeom prst="rect">
+            <a:avLst/>
+          </a:prstGeom>
+          <a:noFill/>
+        </p:spPr>
+        <p:txBody>
+          <a:bodyPr wrap="square" anchor="t" lIns="0" rIns="0" tIns="0" bIns="0">
+            <a:spAutoFit/>
+          </a:bodyPr>
+          <a:lstStyle/>
+          <a:p>
+            <a:pPr algn="l">
+              <a:lnSpc>
+                <a:spcPct val="100000"/>
+              </a:lnSpc>
+              <a:spcAft>
+                <a:spcPts val="400"/>
+              </a:spcAft>
+            </a:pPr>
+            <a:r>
+              <a:rPr sz="1300" b="1" i="0">
+                <a:solidFill>
+                  <a:srgbClr val="059669"/>
+                </a:solidFill>
+                <a:latin typeface="Calibri"/>
+              </a:rPr>
+              <a:t>✓  </a:t>
+            </a:r>
+            <a:r>
+              <a:rPr sz="1250" b="0" i="0">
+                <a:solidFill>
+                  <a:srgbClr val="334155"/>
+                </a:solidFill>
+                <a:latin typeface="Calibri"/>
+              </a:rPr>
+              <a:t>Runs on-premise; no data leaves the company</a:t>
+            </a:r>
+          </a:p>
+        </p:txBody>
+      </p:sp>
+      <p:sp>
+        <p:nvSpPr>
+          <p:cNvPr id="15" name="TextBox 14"/>
+          <p:cNvSpPr txBox="1"/>
+          <p:nvPr/>
+        </p:nvSpPr>
+        <p:spPr>
+          <a:xfrm>
+            <a:off x="685800" y="4709160"/>
+            <a:ext cx="4937760" cy="1005840"/>
+          </a:xfrm>
+          <a:prstGeom prst="rect">
+            <a:avLst/>
+          </a:prstGeom>
+          <a:noFill/>
+        </p:spPr>
+        <p:txBody>
+          <a:bodyPr wrap="square" anchor="t" lIns="0" rIns="0" tIns="0" bIns="0">
+            <a:spAutoFit/>
+          </a:bodyPr>
+          <a:lstStyle/>
+          <a:p>
+            <a:pPr algn="l">
+              <a:lnSpc>
+                <a:spcPct val="115000"/>
+              </a:lnSpc>
+              <a:spcAft>
+                <a:spcPts val="400"/>
+              </a:spcAft>
+            </a:pPr>
+            <a:r>
+              <a:rPr sz="1200" b="1" i="0">
+                <a:solidFill>
+                  <a:srgbClr val="0F172A"/>
+                </a:solidFill>
+                <a:latin typeface="Calibri"/>
+              </a:rPr>
+              <a:t>Honest note: </a:t>
+            </a:r>
+            <a:r>
+              <a:rPr sz="1200" b="0" i="0">
+                <a:solidFill>
+                  <a:srgbClr val="334155"/>
+                </a:solidFill>
+                <a:latin typeface="Calibri"/>
+              </a:rPr>
+              <a:t>the intelligence starts empty and grows with use. The mechanism is proven; the value builds as we feed it.</a:t>
+            </a:r>
+          </a:p>
+        </p:txBody>
+      </p:sp>
+      <p:sp>
+        <p:nvSpPr>
+          <p:cNvPr id="16" name="Rounded Rectangle 15"/>
+          <p:cNvSpPr/>
+          <p:nvPr/>
+        </p:nvSpPr>
+        <p:spPr>
+          <a:xfrm>
+            <a:off x="6263640" y="1828800"/>
+            <a:ext cx="5532120" cy="4023360"/>
+          </a:xfrm>
+          <a:prstGeom prst="roundRect">
+            <a:avLst>
+              <a:gd name="adj" fmla="val 5000"/>
+            </a:avLst>
+          </a:prstGeom>
+          <a:solidFill>
+            <a:srgbClr val="EFF6FF"/>
+          </a:solidFill>
+          <a:ln>
+            <a:noFill/>
+          </a:ln>
+          <a:effectLst/>
+        </p:spPr>
+        <p:style>
+          <a:lnRef idx="1">
+            <a:schemeClr val="accent1"/>
+          </a:lnRef>
+          <a:fillRef idx="3">
+            <a:schemeClr val="accent1"/>
+          </a:fillRef>
+          <a:effectRef idx="2">
+            <a:schemeClr val="accent1"/>
+          </a:effectRef>
+          <a:fontRef idx="minor">
+            <a:schemeClr val="lt1"/>
+          </a:fontRef>
+        </p:style>
+        <p:txBody>
+          <a:bodyPr rtlCol="0" anchor="ctr"/>
+          <a:lstStyle/>
+          <a:p>
+            <a:pPr algn="ctr"/>
+          </a:p>
+        </p:txBody>
+      </p:sp>
+      <p:sp>
+        <p:nvSpPr>
+          <p:cNvPr id="17" name="TextBox 16"/>
+          <p:cNvSpPr txBox="1"/>
+          <p:nvPr/>
+        </p:nvSpPr>
+        <p:spPr>
+          <a:xfrm>
+            <a:off x="6537960" y="2057400"/>
+            <a:ext cx="4937760" cy="365760"/>
+          </a:xfrm>
+          <a:prstGeom prst="rect">
+            <a:avLst/>
+          </a:prstGeom>
+          <a:noFill/>
+        </p:spPr>
+        <p:txBody>
+          <a:bodyPr wrap="square" anchor="t" lIns="0" rIns="0" tIns="0" bIns="0">
+            <a:spAutoFit/>
+          </a:bodyPr>
+          <a:lstStyle/>
+          <a:p>
+            <a:pPr algn="l">
+              <a:lnSpc>
+                <a:spcPct val="100000"/>
+              </a:lnSpc>
+              <a:spcAft>
+                <a:spcPts val="400"/>
+              </a:spcAft>
+            </a:pPr>
+            <a:r>
+              <a:rPr sz="1600" b="1" i="0">
+                <a:solidFill>
+                  <a:srgbClr val="2563EB"/>
+                </a:solidFill>
+                <a:latin typeface="Calibri"/>
+              </a:rPr>
+              <a:t>The ask — three small decisions</a:t>
+            </a:r>
+          </a:p>
+        </p:txBody>
+      </p:sp>
+      <p:sp>
+        <p:nvSpPr>
+          <p:cNvPr id="18" name="TextBox 17"/>
+          <p:cNvSpPr txBox="1"/>
+          <p:nvPr/>
+        </p:nvSpPr>
+        <p:spPr>
+          <a:xfrm>
+            <a:off x="6537960" y="2606040"/>
+            <a:ext cx="5029200" cy="914400"/>
+          </a:xfrm>
+          <a:prstGeom prst="rect">
+            <a:avLst/>
+          </a:prstGeom>
+          <a:noFill/>
+        </p:spPr>
+        <p:txBody>
+          <a:bodyPr wrap="square" anchor="t" lIns="0" rIns="0" tIns="0" bIns="0">
+            <a:spAutoFit/>
+          </a:bodyPr>
+          <a:lstStyle/>
+          <a:p>
+            <a:pPr algn="l">
+              <a:lnSpc>
+                <a:spcPct val="110000"/>
+              </a:lnSpc>
+              <a:spcAft>
+                <a:spcPts val="300"/>
+              </a:spcAft>
+            </a:pPr>
+            <a:r>
+              <a:rPr sz="1350" b="1" i="0">
+                <a:solidFill>
+                  <a:srgbClr val="0F172A"/>
+                </a:solidFill>
+                <a:latin typeface="Calibri"/>
+              </a:rPr>
+              <a:t>1.  Adopt the habit</a:t>
+            </a:r>
+          </a:p>
+          <a:p>
+            <a:pPr algn="l">
+              <a:lnSpc>
+                <a:spcPct val="110000"/>
+              </a:lnSpc>
+              <a:spcAft>
+                <a:spcPts val="300"/>
+              </a:spcAft>
+            </a:pPr>
+            <a:r>
+              <a:rPr sz="1150" b="0" i="0">
+                <a:solidFill>
+                  <a:srgbClr val="334155"/>
+                </a:solidFill>
+                <a:latin typeface="Calibri"/>
+              </a:rPr>
+              <a:t>     Make "Log Actual £" part of the quote-handling routine. One click per quote.</a:t>
+            </a:r>
+          </a:p>
+        </p:txBody>
+      </p:sp>
+      <p:sp>
+        <p:nvSpPr>
+          <p:cNvPr id="19" name="TextBox 18"/>
+          <p:cNvSpPr txBox="1"/>
+          <p:nvPr/>
+        </p:nvSpPr>
+        <p:spPr>
+          <a:xfrm>
+            <a:off x="6537960" y="3566160"/>
+            <a:ext cx="5029200" cy="914400"/>
+          </a:xfrm>
+          <a:prstGeom prst="rect">
+            <a:avLst/>
+          </a:prstGeom>
+          <a:noFill/>
+        </p:spPr>
+        <p:txBody>
+          <a:bodyPr wrap="square" anchor="t" lIns="0" rIns="0" tIns="0" bIns="0">
+            <a:spAutoFit/>
+          </a:bodyPr>
+          <a:lstStyle/>
+          <a:p>
+            <a:pPr algn="l">
+              <a:lnSpc>
+                <a:spcPct val="110000"/>
+              </a:lnSpc>
+              <a:spcAft>
+                <a:spcPts val="300"/>
+              </a:spcAft>
+            </a:pPr>
+            <a:r>
+              <a:rPr sz="1350" b="1" i="0">
+                <a:solidFill>
+                  <a:srgbClr val="0F172A"/>
+                </a:solidFill>
+                <a:latin typeface="Calibri"/>
+              </a:rPr>
+              <a:t>2.  Seed the memory</a:t>
+            </a:r>
+          </a:p>
+          <a:p>
+            <a:pPr algn="l">
+              <a:lnSpc>
+                <a:spcPct val="110000"/>
+              </a:lnSpc>
+              <a:spcAft>
+                <a:spcPts val="300"/>
+              </a:spcAft>
+            </a:pPr>
+            <a:r>
+              <a:rPr sz="1150" b="0" i="0">
+                <a:solidFill>
+                  <a:srgbClr val="334155"/>
+                </a:solidFill>
+                <a:latin typeface="Calibri"/>
+              </a:rPr>
+              <a:t>     Approve a one-off import of historical quotes so the tool starts smart (~1–2 days of effort).</a:t>
+            </a:r>
+          </a:p>
+        </p:txBody>
+      </p:sp>
+      <p:sp>
+        <p:nvSpPr>
+          <p:cNvPr id="20" name="TextBox 19"/>
+          <p:cNvSpPr txBox="1"/>
+          <p:nvPr/>
+        </p:nvSpPr>
+        <p:spPr>
+          <a:xfrm>
+            <a:off x="6537960" y="4526280"/>
+            <a:ext cx="5029200" cy="914400"/>
+          </a:xfrm>
+          <a:prstGeom prst="rect">
+            <a:avLst/>
+          </a:prstGeom>
+          <a:noFill/>
+        </p:spPr>
+        <p:txBody>
+          <a:bodyPr wrap="square" anchor="t" lIns="0" rIns="0" tIns="0" bIns="0">
+            <a:spAutoFit/>
+          </a:bodyPr>
+          <a:lstStyle/>
+          <a:p>
+            <a:pPr algn="l">
+              <a:lnSpc>
+                <a:spcPct val="110000"/>
+              </a:lnSpc>
+              <a:spcAft>
+                <a:spcPts val="300"/>
+              </a:spcAft>
+            </a:pPr>
+            <a:r>
+              <a:rPr sz="1350" b="1" i="0">
+                <a:solidFill>
+                  <a:srgbClr val="0F172A"/>
+                </a:solidFill>
+                <a:latin typeface="Calibri"/>
+              </a:rPr>
+              <a:t>3.  Review the findings</a:t>
+            </a:r>
+          </a:p>
+          <a:p>
+            <a:pPr algn="l">
+              <a:lnSpc>
+                <a:spcPct val="110000"/>
+              </a:lnSpc>
+              <a:spcAft>
+                <a:spcPts val="300"/>
+              </a:spcAft>
+            </a:pPr>
+            <a:r>
+              <a:rPr sz="1150" b="0" i="0">
+                <a:solidFill>
+                  <a:srgbClr val="334155"/>
+                </a:solidFill>
+                <a:latin typeface="Calibri"/>
+              </a:rPr>
+              <a:t>     Put the agent's monthly findings on the sourcing team's agenda — it is already finding money.</a:t>
+            </a:r>
+          </a:p>
+        </p:txBody>
+      </p:sp>
+      <p:sp>
+        <p:nvSpPr>
+          <p:cNvPr id="21" name="Rectangle 20"/>
+          <p:cNvSpPr/>
+          <p:nvPr/>
+        </p:nvSpPr>
+        <p:spPr>
+          <a:xfrm>
+            <a:off x="0" y="6711696"/>
+            <a:ext cx="12191695" cy="146304"/>
+          </a:xfrm>
+          <a:prstGeom prst="rect">
+            <a:avLst/>
+          </a:prstGeom>
+          <a:solidFill>
+            <a:srgbClr val="4F46E5"/>
+          </a:solidFill>
+          <a:ln>
+            <a:noFill/>
+          </a:ln>
+          <a:effectLst/>
+        </p:spPr>
+        <p:style>
+          <a:lnRef idx="1">
+            <a:schemeClr val="accent1"/>
+          </a:lnRef>
+          <a:fillRef idx="3">
+            <a:schemeClr val="accent1"/>
+          </a:fillRef>
+          <a:effectRef idx="2">
+            <a:schemeClr val="accent1"/>
+          </a:effectRef>
+          <a:fontRef idx="minor">
+            <a:schemeClr val="lt1"/>
+          </a:fontRef>
+        </p:style>
+        <p:txBody>
+          <a:bodyPr rtlCol="0" anchor="ctr"/>
+          <a:lstStyle/>
+          <a:p>
+            <a:pPr algn="ctr"/>
           </a:p>
         </p:txBody>
       </p:sp>

</xml_diff>